<commit_message>
ajustes_finales: Se realizan ajustes finales sobre documentación se ordenan los codigos y se actualiza README
</commit_message>
<xml_diff>
--- a/docs/Diagramas.pptx
+++ b/docs/Diagramas.pptx
@@ -5,11 +5,12 @@
     <p:sldMasterId id="2147483648" r:id="rId1"/>
   </p:sldMasterIdLst>
   <p:notesMasterIdLst>
-    <p:notesMasterId r:id="rId4"/>
+    <p:notesMasterId r:id="rId5"/>
   </p:notesMasterIdLst>
   <p:sldIdLst>
     <p:sldId id="256" r:id="rId2"/>
     <p:sldId id="257" r:id="rId3"/>
+    <p:sldId id="258" r:id="rId4"/>
   </p:sldIdLst>
   <p:sldSz cx="12192000" cy="6858000"/>
   <p:notesSz cx="6858000" cy="9144000"/>
@@ -108,6 +109,11 @@
       </a:defRPr>
     </a:lvl9pPr>
   </p:defaultTextStyle>
+  <p:extLst>
+    <p:ext uri="{EFAFB233-063F-42B5-8137-9DF3F51BA10A}">
+      <p15:sldGuideLst xmlns:p15="http://schemas.microsoft.com/office/powerpoint/2012/main"/>
+    </p:ext>
+  </p:extLst>
 </p:presentation>
 </file>
 
@@ -193,7 +199,7 @@
           <a:p>
             <a:fld id="{D9038A1C-327E-444F-A64E-F08B27DF9DB9}" type="datetimeFigureOut">
               <a:rPr lang="es-CO" smtClean="0"/>
-              <a:t>13/09/2026</a:t>
+              <a:t>14/09/2026</a:t>
             </a:fld>
             <a:endParaRPr lang="es-CO"/>
           </a:p>
@@ -610,7 +616,7 @@
           <a:p>
             <a:fld id="{5CEE3C45-DD15-4547-82D4-C6128F8E42A0}" type="datetimeFigureOut">
               <a:rPr lang="es-CO" smtClean="0"/>
-              <a:t>13/09/2026</a:t>
+              <a:t>14/09/2026</a:t>
             </a:fld>
             <a:endParaRPr lang="es-CO"/>
           </a:p>
@@ -810,7 +816,7 @@
           <a:p>
             <a:fld id="{5CEE3C45-DD15-4547-82D4-C6128F8E42A0}" type="datetimeFigureOut">
               <a:rPr lang="es-CO" smtClean="0"/>
-              <a:t>13/09/2026</a:t>
+              <a:t>14/09/2026</a:t>
             </a:fld>
             <a:endParaRPr lang="es-CO"/>
           </a:p>
@@ -1020,7 +1026,7 @@
           <a:p>
             <a:fld id="{5CEE3C45-DD15-4547-82D4-C6128F8E42A0}" type="datetimeFigureOut">
               <a:rPr lang="es-CO" smtClean="0"/>
-              <a:t>13/09/2026</a:t>
+              <a:t>14/09/2026</a:t>
             </a:fld>
             <a:endParaRPr lang="es-CO"/>
           </a:p>
@@ -1220,7 +1226,7 @@
           <a:p>
             <a:fld id="{5CEE3C45-DD15-4547-82D4-C6128F8E42A0}" type="datetimeFigureOut">
               <a:rPr lang="es-CO" smtClean="0"/>
-              <a:t>13/09/2026</a:t>
+              <a:t>14/09/2026</a:t>
             </a:fld>
             <a:endParaRPr lang="es-CO"/>
           </a:p>
@@ -1496,7 +1502,7 @@
           <a:p>
             <a:fld id="{5CEE3C45-DD15-4547-82D4-C6128F8E42A0}" type="datetimeFigureOut">
               <a:rPr lang="es-CO" smtClean="0"/>
-              <a:t>13/09/2026</a:t>
+              <a:t>14/09/2026</a:t>
             </a:fld>
             <a:endParaRPr lang="es-CO"/>
           </a:p>
@@ -1764,7 +1770,7 @@
           <a:p>
             <a:fld id="{5CEE3C45-DD15-4547-82D4-C6128F8E42A0}" type="datetimeFigureOut">
               <a:rPr lang="es-CO" smtClean="0"/>
-              <a:t>13/09/2026</a:t>
+              <a:t>14/09/2026</a:t>
             </a:fld>
             <a:endParaRPr lang="es-CO"/>
           </a:p>
@@ -2179,7 +2185,7 @@
           <a:p>
             <a:fld id="{5CEE3C45-DD15-4547-82D4-C6128F8E42A0}" type="datetimeFigureOut">
               <a:rPr lang="es-CO" smtClean="0"/>
-              <a:t>13/09/2026</a:t>
+              <a:t>14/09/2026</a:t>
             </a:fld>
             <a:endParaRPr lang="es-CO"/>
           </a:p>
@@ -2321,7 +2327,7 @@
           <a:p>
             <a:fld id="{5CEE3C45-DD15-4547-82D4-C6128F8E42A0}" type="datetimeFigureOut">
               <a:rPr lang="es-CO" smtClean="0"/>
-              <a:t>13/09/2026</a:t>
+              <a:t>14/09/2026</a:t>
             </a:fld>
             <a:endParaRPr lang="es-CO"/>
           </a:p>
@@ -2434,7 +2440,7 @@
           <a:p>
             <a:fld id="{5CEE3C45-DD15-4547-82D4-C6128F8E42A0}" type="datetimeFigureOut">
               <a:rPr lang="es-CO" smtClean="0"/>
-              <a:t>13/09/2026</a:t>
+              <a:t>14/09/2026</a:t>
             </a:fld>
             <a:endParaRPr lang="es-CO"/>
           </a:p>
@@ -2747,7 +2753,7 @@
           <a:p>
             <a:fld id="{5CEE3C45-DD15-4547-82D4-C6128F8E42A0}" type="datetimeFigureOut">
               <a:rPr lang="es-CO" smtClean="0"/>
-              <a:t>13/09/2026</a:t>
+              <a:t>14/09/2026</a:t>
             </a:fld>
             <a:endParaRPr lang="es-CO"/>
           </a:p>
@@ -3036,7 +3042,7 @@
           <a:p>
             <a:fld id="{5CEE3C45-DD15-4547-82D4-C6128F8E42A0}" type="datetimeFigureOut">
               <a:rPr lang="es-CO" smtClean="0"/>
-              <a:t>13/09/2026</a:t>
+              <a:t>14/09/2026</a:t>
             </a:fld>
             <a:endParaRPr lang="es-CO"/>
           </a:p>
@@ -3279,7 +3285,7 @@
           <a:p>
             <a:fld id="{5CEE3C45-DD15-4547-82D4-C6128F8E42A0}" type="datetimeFigureOut">
               <a:rPr lang="es-CO" smtClean="0"/>
-              <a:t>13/09/2026</a:t>
+              <a:t>14/09/2026</a:t>
             </a:fld>
             <a:endParaRPr lang="es-CO"/>
           </a:p>
@@ -4332,7 +4338,7 @@
         <p:spPr>
           <a:xfrm>
             <a:off x="8770129" y="3173476"/>
-            <a:ext cx="2862733" cy="584775"/>
+            <a:ext cx="3117071" cy="584775"/>
           </a:xfrm>
           <a:prstGeom prst="rect">
             <a:avLst/>
@@ -4347,13 +4353,13 @@
           <a:p>
             <a:r>
               <a:rPr lang="es-CO" sz="1600" b="1" dirty="0"/>
-              <a:t>1: Cliente acepta opción</a:t>
+              <a:t>1: Cliente aceptará opción</a:t>
             </a:r>
           </a:p>
           <a:p>
             <a:r>
               <a:rPr lang="es-CO" sz="1600" b="1" dirty="0"/>
-              <a:t>2: Cliente no acepta opción</a:t>
+              <a:t>0: Cliente no aceptará opción</a:t>
             </a:r>
           </a:p>
         </p:txBody>
@@ -6935,22 +6941,28 @@
               <a:defRPr/>
             </a:pPr>
             <a:r>
-              <a:rPr kumimoji="0" lang="es-CO" sz="1100" b="1" i="0" u="none" strike="noStrike" kern="1200" cap="none" spc="0" normalizeH="0" baseline="0" noProof="0" dirty="0">
-                <a:ln>
-                  <a:noFill/>
-                </a:ln>
+              <a:rPr lang="es-CO" sz="1100" b="1" dirty="0">
                 <a:solidFill>
                   <a:srgbClr val="2C2A28"/>
                 </a:solidFill>
-                <a:effectLst/>
-                <a:uLnTx/>
-                <a:uFillTx/>
                 <a:latin typeface="CIBFont Sans Light" panose="020B0603020202020104" pitchFamily="34" charset="0"/>
-                <a:ea typeface="+mn-ea"/>
-                <a:cs typeface="+mn-cs"/>
               </a:rPr>
-              <a:t>Clientes potenciales</a:t>
-            </a:r>
+              <a:t>Conocimiento cliente</a:t>
+            </a:r>
+            <a:endParaRPr kumimoji="0" lang="es-CO" sz="1100" b="1" i="0" u="none" strike="noStrike" kern="1200" cap="none" spc="0" normalizeH="0" baseline="0" noProof="0" dirty="0">
+              <a:ln>
+                <a:noFill/>
+              </a:ln>
+              <a:solidFill>
+                <a:srgbClr val="2C2A28"/>
+              </a:solidFill>
+              <a:effectLst/>
+              <a:uLnTx/>
+              <a:uFillTx/>
+              <a:latin typeface="CIBFont Sans Light" panose="020B0603020202020104" pitchFamily="34" charset="0"/>
+              <a:ea typeface="+mn-ea"/>
+              <a:cs typeface="+mn-cs"/>
+            </a:endParaRPr>
           </a:p>
         </p:txBody>
       </p:sp>
@@ -10562,6 +10574,2295 @@
     <p:extLst>
       <p:ext uri="{BB962C8B-B14F-4D97-AF65-F5344CB8AC3E}">
         <p14:creationId xmlns:p14="http://schemas.microsoft.com/office/powerpoint/2010/main" val="3139822584"/>
+      </p:ext>
+    </p:extLst>
+  </p:cSld>
+  <p:clrMapOvr>
+    <a:masterClrMapping/>
+  </p:clrMapOvr>
+</p:sld>
+</file>
+
+<file path=ppt/slides/slide3.xml><?xml version="1.0" encoding="utf-8"?>
+<p:sld xmlns:a="http://schemas.openxmlformats.org/drawingml/2006/main" xmlns:r="http://schemas.openxmlformats.org/officeDocument/2006/relationships" xmlns:p="http://schemas.openxmlformats.org/presentationml/2006/main">
+  <p:cSld>
+    <p:spTree>
+      <p:nvGrpSpPr>
+        <p:cNvPr id="1" name="">
+          <a:extLst>
+            <a:ext uri="{FF2B5EF4-FFF2-40B4-BE49-F238E27FC236}">
+              <a16:creationId xmlns:a16="http://schemas.microsoft.com/office/drawing/2014/main" id="{2FAF6F32-2192-D058-93B2-2529CE9494E4}"/>
+            </a:ext>
+          </a:extLst>
+        </p:cNvPr>
+        <p:cNvGrpSpPr/>
+        <p:nvPr/>
+      </p:nvGrpSpPr>
+      <p:grpSpPr>
+        <a:xfrm>
+          <a:off x="0" y="0"/>
+          <a:ext cx="0" cy="0"/>
+          <a:chOff x="0" y="0"/>
+          <a:chExt cx="0" cy="0"/>
+        </a:xfrm>
+      </p:grpSpPr>
+      <p:pic>
+        <p:nvPicPr>
+          <p:cNvPr id="2" name="Imagen 1">
+            <a:extLst>
+              <a:ext uri="{FF2B5EF4-FFF2-40B4-BE49-F238E27FC236}">
+                <a16:creationId xmlns:a16="http://schemas.microsoft.com/office/drawing/2014/main" id="{71B3BA2E-1877-8037-B684-793D5E084A25}"/>
+              </a:ext>
+            </a:extLst>
+          </p:cNvPr>
+          <p:cNvPicPr>
+            <a:picLocks noChangeAspect="1"/>
+          </p:cNvPicPr>
+          <p:nvPr/>
+        </p:nvPicPr>
+        <p:blipFill>
+          <a:blip r:embed="rId2"/>
+          <a:stretch>
+            <a:fillRect/>
+          </a:stretch>
+        </p:blipFill>
+        <p:spPr>
+          <a:xfrm>
+            <a:off x="1152612" y="2415529"/>
+            <a:ext cx="600161" cy="600161"/>
+          </a:xfrm>
+          <a:prstGeom prst="rect">
+            <a:avLst/>
+          </a:prstGeom>
+        </p:spPr>
+      </p:pic>
+      <p:sp>
+        <p:nvSpPr>
+          <p:cNvPr id="3" name="CuadroTexto 2">
+            <a:extLst>
+              <a:ext uri="{FF2B5EF4-FFF2-40B4-BE49-F238E27FC236}">
+                <a16:creationId xmlns:a16="http://schemas.microsoft.com/office/drawing/2014/main" id="{2133CB6B-7BCC-FF05-BD10-4729FDE5F427}"/>
+              </a:ext>
+            </a:extLst>
+          </p:cNvPr>
+          <p:cNvSpPr txBox="1"/>
+          <p:nvPr/>
+        </p:nvSpPr>
+        <p:spPr>
+          <a:xfrm>
+            <a:off x="856552" y="3100179"/>
+            <a:ext cx="1192277" cy="430887"/>
+          </a:xfrm>
+          <a:prstGeom prst="rect">
+            <a:avLst/>
+          </a:prstGeom>
+          <a:noFill/>
+        </p:spPr>
+        <p:txBody>
+          <a:bodyPr wrap="square">
+            <a:spAutoFit/>
+          </a:bodyPr>
+          <a:lstStyle/>
+          <a:p>
+            <a:pPr marL="0" marR="0" lvl="0" indent="0" algn="ctr" defTabSz="914400" rtl="0" eaLnBrk="1" fontAlgn="auto" latinLnBrk="0" hangingPunct="1">
+              <a:lnSpc>
+                <a:spcPct val="100000"/>
+              </a:lnSpc>
+              <a:spcBef>
+                <a:spcPts val="0"/>
+              </a:spcBef>
+              <a:spcAft>
+                <a:spcPts val="0"/>
+              </a:spcAft>
+              <a:buClrTx/>
+              <a:buSzTx/>
+              <a:buFontTx/>
+              <a:buNone/>
+              <a:tabLst/>
+              <a:defRPr/>
+            </a:pPr>
+            <a:r>
+              <a:rPr kumimoji="0" lang="es-CO" sz="1100" b="1" i="0" u="none" strike="noStrike" kern="1200" cap="none" spc="0" normalizeH="0" baseline="0" noProof="0" dirty="0">
+                <a:ln>
+                  <a:noFill/>
+                </a:ln>
+                <a:solidFill>
+                  <a:srgbClr val="2C2A28"/>
+                </a:solidFill>
+                <a:effectLst/>
+                <a:uLnTx/>
+                <a:uFillTx/>
+                <a:latin typeface="CIBFont Sans Light" panose="020B0603020202020104" pitchFamily="34" charset="0"/>
+                <a:ea typeface="+mn-ea"/>
+                <a:cs typeface="+mn-cs"/>
+              </a:rPr>
+              <a:t>API interacción de datos</a:t>
+            </a:r>
+          </a:p>
+        </p:txBody>
+      </p:sp>
+      <p:pic>
+        <p:nvPicPr>
+          <p:cNvPr id="4" name="Imagen 3">
+            <a:extLst>
+              <a:ext uri="{FF2B5EF4-FFF2-40B4-BE49-F238E27FC236}">
+                <a16:creationId xmlns:a16="http://schemas.microsoft.com/office/drawing/2014/main" id="{02F9F95C-92F1-C689-3AA5-D8EB417FE593}"/>
+              </a:ext>
+            </a:extLst>
+          </p:cNvPr>
+          <p:cNvPicPr>
+            <a:picLocks noChangeAspect="1"/>
+          </p:cNvPicPr>
+          <p:nvPr/>
+        </p:nvPicPr>
+        <p:blipFill>
+          <a:blip r:embed="rId3"/>
+          <a:stretch>
+            <a:fillRect/>
+          </a:stretch>
+        </p:blipFill>
+        <p:spPr>
+          <a:xfrm>
+            <a:off x="2377091" y="2377203"/>
+            <a:ext cx="691343" cy="691343"/>
+          </a:xfrm>
+          <a:prstGeom prst="rect">
+            <a:avLst/>
+          </a:prstGeom>
+        </p:spPr>
+      </p:pic>
+      <p:sp>
+        <p:nvSpPr>
+          <p:cNvPr id="6" name="CuadroTexto 5">
+            <a:extLst>
+              <a:ext uri="{FF2B5EF4-FFF2-40B4-BE49-F238E27FC236}">
+                <a16:creationId xmlns:a16="http://schemas.microsoft.com/office/drawing/2014/main" id="{2ED72E75-4E4B-B456-F4CC-2C6CDF3D9541}"/>
+              </a:ext>
+            </a:extLst>
+          </p:cNvPr>
+          <p:cNvSpPr txBox="1"/>
+          <p:nvPr/>
+        </p:nvSpPr>
+        <p:spPr>
+          <a:xfrm>
+            <a:off x="2126623" y="3142936"/>
+            <a:ext cx="1192277" cy="261610"/>
+          </a:xfrm>
+          <a:prstGeom prst="rect">
+            <a:avLst/>
+          </a:prstGeom>
+          <a:noFill/>
+        </p:spPr>
+        <p:txBody>
+          <a:bodyPr wrap="square">
+            <a:spAutoFit/>
+          </a:bodyPr>
+          <a:lstStyle/>
+          <a:p>
+            <a:pPr marL="0" marR="0" lvl="0" indent="0" algn="ctr" defTabSz="914400" rtl="0" eaLnBrk="1" fontAlgn="auto" latinLnBrk="0" hangingPunct="1">
+              <a:lnSpc>
+                <a:spcPct val="100000"/>
+              </a:lnSpc>
+              <a:spcBef>
+                <a:spcPts val="0"/>
+              </a:spcBef>
+              <a:spcAft>
+                <a:spcPts val="0"/>
+              </a:spcAft>
+              <a:buClrTx/>
+              <a:buSzTx/>
+              <a:buFontTx/>
+              <a:buNone/>
+              <a:tabLst/>
+              <a:defRPr/>
+            </a:pPr>
+            <a:r>
+              <a:rPr kumimoji="0" lang="es-CO" sz="1100" b="1" i="0" u="none" strike="noStrike" kern="1200" cap="none" spc="0" normalizeH="0" baseline="0" noProof="0" dirty="0">
+                <a:ln>
+                  <a:noFill/>
+                </a:ln>
+                <a:solidFill>
+                  <a:srgbClr val="2C2A28"/>
+                </a:solidFill>
+                <a:effectLst/>
+                <a:uLnTx/>
+                <a:uFillTx/>
+                <a:latin typeface="CIBFont Sans Light" panose="020B0603020202020104" pitchFamily="34" charset="0"/>
+                <a:ea typeface="+mn-ea"/>
+                <a:cs typeface="+mn-cs"/>
+              </a:rPr>
+              <a:t>MCP</a:t>
+            </a:r>
+          </a:p>
+        </p:txBody>
+      </p:sp>
+      <p:cxnSp>
+        <p:nvCxnSpPr>
+          <p:cNvPr id="8" name="Conector recto de flecha 7">
+            <a:extLst>
+              <a:ext uri="{FF2B5EF4-FFF2-40B4-BE49-F238E27FC236}">
+                <a16:creationId xmlns:a16="http://schemas.microsoft.com/office/drawing/2014/main" id="{A1ADE951-C875-1304-58EB-38B54BC5FD50}"/>
+              </a:ext>
+            </a:extLst>
+          </p:cNvPr>
+          <p:cNvCxnSpPr>
+            <a:cxnSpLocks/>
+            <a:stCxn id="2" idx="3"/>
+            <a:endCxn id="4" idx="1"/>
+          </p:cNvCxnSpPr>
+          <p:nvPr/>
+        </p:nvCxnSpPr>
+        <p:spPr>
+          <a:xfrm>
+            <a:off x="1752773" y="2715610"/>
+            <a:ext cx="624318" cy="7265"/>
+          </a:xfrm>
+          <a:prstGeom prst="straightConnector1">
+            <a:avLst/>
+          </a:prstGeom>
+          <a:ln>
+            <a:headEnd type="triangle" w="med" len="med"/>
+            <a:tailEnd type="triangle" w="med" len="med"/>
+          </a:ln>
+        </p:spPr>
+        <p:style>
+          <a:lnRef idx="2">
+            <a:schemeClr val="dk1"/>
+          </a:lnRef>
+          <a:fillRef idx="0">
+            <a:schemeClr val="dk1"/>
+          </a:fillRef>
+          <a:effectRef idx="1">
+            <a:schemeClr val="dk1"/>
+          </a:effectRef>
+          <a:fontRef idx="minor">
+            <a:schemeClr val="tx1"/>
+          </a:fontRef>
+        </p:style>
+      </p:cxnSp>
+      <p:cxnSp>
+        <p:nvCxnSpPr>
+          <p:cNvPr id="10" name="Conector recto de flecha 9">
+            <a:extLst>
+              <a:ext uri="{FF2B5EF4-FFF2-40B4-BE49-F238E27FC236}">
+                <a16:creationId xmlns:a16="http://schemas.microsoft.com/office/drawing/2014/main" id="{E0492D76-3D17-5874-D975-7169360DD669}"/>
+              </a:ext>
+            </a:extLst>
+          </p:cNvPr>
+          <p:cNvCxnSpPr>
+            <a:cxnSpLocks/>
+            <a:stCxn id="4" idx="3"/>
+            <a:endCxn id="51" idx="1"/>
+          </p:cNvCxnSpPr>
+          <p:nvPr/>
+        </p:nvCxnSpPr>
+        <p:spPr>
+          <a:xfrm flipV="1">
+            <a:off x="3068434" y="2715610"/>
+            <a:ext cx="624319" cy="7265"/>
+          </a:xfrm>
+          <a:prstGeom prst="straightConnector1">
+            <a:avLst/>
+          </a:prstGeom>
+          <a:ln>
+            <a:headEnd type="triangle" w="med" len="med"/>
+            <a:tailEnd type="triangle" w="med" len="med"/>
+          </a:ln>
+        </p:spPr>
+        <p:style>
+          <a:lnRef idx="2">
+            <a:schemeClr val="dk1"/>
+          </a:lnRef>
+          <a:fillRef idx="0">
+            <a:schemeClr val="dk1"/>
+          </a:fillRef>
+          <a:effectRef idx="1">
+            <a:schemeClr val="dk1"/>
+          </a:effectRef>
+          <a:fontRef idx="minor">
+            <a:schemeClr val="tx1"/>
+          </a:fontRef>
+        </p:style>
+      </p:cxnSp>
+      <p:pic>
+        <p:nvPicPr>
+          <p:cNvPr id="14" name="Imagen 13">
+            <a:extLst>
+              <a:ext uri="{FF2B5EF4-FFF2-40B4-BE49-F238E27FC236}">
+                <a16:creationId xmlns:a16="http://schemas.microsoft.com/office/drawing/2014/main" id="{BF9DC5F3-9A4C-703D-1938-178C4051A1A4}"/>
+              </a:ext>
+            </a:extLst>
+          </p:cNvPr>
+          <p:cNvPicPr>
+            <a:picLocks noChangeAspect="1"/>
+          </p:cNvPicPr>
+          <p:nvPr/>
+        </p:nvPicPr>
+        <p:blipFill>
+          <a:blip r:embed="rId4"/>
+          <a:stretch>
+            <a:fillRect/>
+          </a:stretch>
+        </p:blipFill>
+        <p:spPr>
+          <a:xfrm>
+            <a:off x="2408274" y="4143917"/>
+            <a:ext cx="801697" cy="801697"/>
+          </a:xfrm>
+          <a:prstGeom prst="rect">
+            <a:avLst/>
+          </a:prstGeom>
+        </p:spPr>
+      </p:pic>
+      <p:pic>
+        <p:nvPicPr>
+          <p:cNvPr id="19" name="Imagen 18">
+            <a:extLst>
+              <a:ext uri="{FF2B5EF4-FFF2-40B4-BE49-F238E27FC236}">
+                <a16:creationId xmlns:a16="http://schemas.microsoft.com/office/drawing/2014/main" id="{2F5E8ECA-3714-D962-A2F0-F0536776FAA0}"/>
+              </a:ext>
+            </a:extLst>
+          </p:cNvPr>
+          <p:cNvPicPr>
+            <a:picLocks noChangeAspect="1"/>
+          </p:cNvPicPr>
+          <p:nvPr/>
+        </p:nvPicPr>
+        <p:blipFill>
+          <a:blip r:embed="rId5"/>
+          <a:stretch>
+            <a:fillRect/>
+          </a:stretch>
+        </p:blipFill>
+        <p:spPr>
+          <a:xfrm>
+            <a:off x="5077615" y="2249932"/>
+            <a:ext cx="925564" cy="925564"/>
+          </a:xfrm>
+          <a:prstGeom prst="rect">
+            <a:avLst/>
+          </a:prstGeom>
+        </p:spPr>
+      </p:pic>
+      <p:pic>
+        <p:nvPicPr>
+          <p:cNvPr id="22" name="Imagen 21">
+            <a:extLst>
+              <a:ext uri="{FF2B5EF4-FFF2-40B4-BE49-F238E27FC236}">
+                <a16:creationId xmlns:a16="http://schemas.microsoft.com/office/drawing/2014/main" id="{87BB5AB6-A05E-62CE-5FE1-8416B83CC200}"/>
+              </a:ext>
+            </a:extLst>
+          </p:cNvPr>
+          <p:cNvPicPr>
+            <a:picLocks noChangeAspect="1"/>
+          </p:cNvPicPr>
+          <p:nvPr/>
+        </p:nvPicPr>
+        <p:blipFill>
+          <a:blip r:embed="rId6"/>
+          <a:stretch>
+            <a:fillRect/>
+          </a:stretch>
+        </p:blipFill>
+        <p:spPr>
+          <a:xfrm>
+            <a:off x="8204651" y="813916"/>
+            <a:ext cx="925564" cy="925564"/>
+          </a:xfrm>
+          <a:prstGeom prst="rect">
+            <a:avLst/>
+          </a:prstGeom>
+        </p:spPr>
+      </p:pic>
+      <p:sp>
+        <p:nvSpPr>
+          <p:cNvPr id="33" name="CuadroTexto 32">
+            <a:extLst>
+              <a:ext uri="{FF2B5EF4-FFF2-40B4-BE49-F238E27FC236}">
+                <a16:creationId xmlns:a16="http://schemas.microsoft.com/office/drawing/2014/main" id="{AB2CB594-C0A4-2DD0-2FE1-90D79E4B53BD}"/>
+              </a:ext>
+            </a:extLst>
+          </p:cNvPr>
+          <p:cNvSpPr txBox="1"/>
+          <p:nvPr/>
+        </p:nvSpPr>
+        <p:spPr>
+          <a:xfrm>
+            <a:off x="2212983" y="5009779"/>
+            <a:ext cx="1192277" cy="261610"/>
+          </a:xfrm>
+          <a:prstGeom prst="rect">
+            <a:avLst/>
+          </a:prstGeom>
+          <a:noFill/>
+        </p:spPr>
+        <p:txBody>
+          <a:bodyPr wrap="square">
+            <a:spAutoFit/>
+          </a:bodyPr>
+          <a:lstStyle/>
+          <a:p>
+            <a:pPr marL="0" marR="0" lvl="0" indent="0" algn="ctr" defTabSz="914400" rtl="0" eaLnBrk="1" fontAlgn="auto" latinLnBrk="0" hangingPunct="1">
+              <a:lnSpc>
+                <a:spcPct val="100000"/>
+              </a:lnSpc>
+              <a:spcBef>
+                <a:spcPts val="0"/>
+              </a:spcBef>
+              <a:spcAft>
+                <a:spcPts val="0"/>
+              </a:spcAft>
+              <a:buClrTx/>
+              <a:buSzTx/>
+              <a:buFontTx/>
+              <a:buNone/>
+              <a:tabLst/>
+              <a:defRPr/>
+            </a:pPr>
+            <a:r>
+              <a:rPr kumimoji="0" lang="es-CO" sz="1100" b="1" i="0" u="none" strike="noStrike" kern="1200" cap="none" spc="0" normalizeH="0" baseline="0" noProof="0" dirty="0">
+                <a:ln>
+                  <a:noFill/>
+                </a:ln>
+                <a:solidFill>
+                  <a:srgbClr val="2C2A28"/>
+                </a:solidFill>
+                <a:effectLst/>
+                <a:uLnTx/>
+                <a:uFillTx/>
+                <a:latin typeface="CIBFont Sans Light" panose="020B0603020202020104" pitchFamily="34" charset="0"/>
+                <a:ea typeface="+mn-ea"/>
+                <a:cs typeface="+mn-cs"/>
+              </a:rPr>
+              <a:t>Cliente</a:t>
+            </a:r>
+          </a:p>
+        </p:txBody>
+      </p:sp>
+      <p:pic>
+        <p:nvPicPr>
+          <p:cNvPr id="37" name="Imagen 36">
+            <a:extLst>
+              <a:ext uri="{FF2B5EF4-FFF2-40B4-BE49-F238E27FC236}">
+                <a16:creationId xmlns:a16="http://schemas.microsoft.com/office/drawing/2014/main" id="{2095F882-D7D1-6C55-888F-BCB5F07CCA00}"/>
+              </a:ext>
+            </a:extLst>
+          </p:cNvPr>
+          <p:cNvPicPr>
+            <a:picLocks noChangeAspect="1"/>
+          </p:cNvPicPr>
+          <p:nvPr/>
+        </p:nvPicPr>
+        <p:blipFill>
+          <a:blip r:embed="rId7"/>
+          <a:stretch>
+            <a:fillRect/>
+          </a:stretch>
+        </p:blipFill>
+        <p:spPr>
+          <a:xfrm>
+            <a:off x="6541074" y="2240954"/>
+            <a:ext cx="943520" cy="943520"/>
+          </a:xfrm>
+          <a:prstGeom prst="rect">
+            <a:avLst/>
+          </a:prstGeom>
+        </p:spPr>
+      </p:pic>
+      <p:pic>
+        <p:nvPicPr>
+          <p:cNvPr id="41" name="Imagen 40">
+            <a:extLst>
+              <a:ext uri="{FF2B5EF4-FFF2-40B4-BE49-F238E27FC236}">
+                <a16:creationId xmlns:a16="http://schemas.microsoft.com/office/drawing/2014/main" id="{7FB5A82A-36CF-7CC6-546F-C5B3EE7594A8}"/>
+              </a:ext>
+            </a:extLst>
+          </p:cNvPr>
+          <p:cNvPicPr>
+            <a:picLocks noChangeAspect="1"/>
+          </p:cNvPicPr>
+          <p:nvPr/>
+        </p:nvPicPr>
+        <p:blipFill>
+          <a:blip r:embed="rId6"/>
+          <a:stretch>
+            <a:fillRect/>
+          </a:stretch>
+        </p:blipFill>
+        <p:spPr>
+          <a:xfrm>
+            <a:off x="8181182" y="2253843"/>
+            <a:ext cx="925564" cy="925564"/>
+          </a:xfrm>
+          <a:prstGeom prst="rect">
+            <a:avLst/>
+          </a:prstGeom>
+        </p:spPr>
+      </p:pic>
+      <p:pic>
+        <p:nvPicPr>
+          <p:cNvPr id="45" name="Imagen 44">
+            <a:extLst>
+              <a:ext uri="{FF2B5EF4-FFF2-40B4-BE49-F238E27FC236}">
+                <a16:creationId xmlns:a16="http://schemas.microsoft.com/office/drawing/2014/main" id="{4E4C32E9-6D27-77C3-E4EF-339989915C02}"/>
+              </a:ext>
+            </a:extLst>
+          </p:cNvPr>
+          <p:cNvPicPr>
+            <a:picLocks noChangeAspect="1"/>
+          </p:cNvPicPr>
+          <p:nvPr/>
+        </p:nvPicPr>
+        <p:blipFill>
+          <a:blip r:embed="rId6"/>
+          <a:stretch>
+            <a:fillRect/>
+          </a:stretch>
+        </p:blipFill>
+        <p:spPr>
+          <a:xfrm>
+            <a:off x="8202446" y="3629757"/>
+            <a:ext cx="925564" cy="925564"/>
+          </a:xfrm>
+          <a:prstGeom prst="rect">
+            <a:avLst/>
+          </a:prstGeom>
+        </p:spPr>
+      </p:pic>
+      <p:pic>
+        <p:nvPicPr>
+          <p:cNvPr id="51" name="Imagen 50">
+            <a:extLst>
+              <a:ext uri="{FF2B5EF4-FFF2-40B4-BE49-F238E27FC236}">
+                <a16:creationId xmlns:a16="http://schemas.microsoft.com/office/drawing/2014/main" id="{1CF2E01B-A801-5E53-3482-61FC22C12A32}"/>
+              </a:ext>
+            </a:extLst>
+          </p:cNvPr>
+          <p:cNvPicPr>
+            <a:picLocks noChangeAspect="1"/>
+          </p:cNvPicPr>
+          <p:nvPr/>
+        </p:nvPicPr>
+        <p:blipFill>
+          <a:blip r:embed="rId8"/>
+          <a:stretch>
+            <a:fillRect/>
+          </a:stretch>
+        </p:blipFill>
+        <p:spPr>
+          <a:xfrm>
+            <a:off x="3692753" y="2295548"/>
+            <a:ext cx="840124" cy="840124"/>
+          </a:xfrm>
+          <a:prstGeom prst="rect">
+            <a:avLst/>
+          </a:prstGeom>
+        </p:spPr>
+      </p:pic>
+      <p:pic>
+        <p:nvPicPr>
+          <p:cNvPr id="53" name="Imagen 52">
+            <a:extLst>
+              <a:ext uri="{FF2B5EF4-FFF2-40B4-BE49-F238E27FC236}">
+                <a16:creationId xmlns:a16="http://schemas.microsoft.com/office/drawing/2014/main" id="{6E5585DF-56E4-E673-1F34-F1B3B5041E12}"/>
+              </a:ext>
+            </a:extLst>
+          </p:cNvPr>
+          <p:cNvPicPr>
+            <a:picLocks noChangeAspect="1"/>
+          </p:cNvPicPr>
+          <p:nvPr/>
+        </p:nvPicPr>
+        <p:blipFill>
+          <a:blip r:embed="rId9"/>
+          <a:stretch>
+            <a:fillRect/>
+          </a:stretch>
+        </p:blipFill>
+        <p:spPr>
+          <a:xfrm>
+            <a:off x="3750382" y="4095973"/>
+            <a:ext cx="897585" cy="897585"/>
+          </a:xfrm>
+          <a:prstGeom prst="rect">
+            <a:avLst/>
+          </a:prstGeom>
+        </p:spPr>
+      </p:pic>
+      <p:pic>
+        <p:nvPicPr>
+          <p:cNvPr id="55" name="Imagen 54">
+            <a:extLst>
+              <a:ext uri="{FF2B5EF4-FFF2-40B4-BE49-F238E27FC236}">
+                <a16:creationId xmlns:a16="http://schemas.microsoft.com/office/drawing/2014/main" id="{C9AA5A0B-FFE8-09DE-EB41-9AC921CB259D}"/>
+              </a:ext>
+            </a:extLst>
+          </p:cNvPr>
+          <p:cNvPicPr>
+            <a:picLocks noChangeAspect="1"/>
+          </p:cNvPicPr>
+          <p:nvPr/>
+        </p:nvPicPr>
+        <p:blipFill>
+          <a:blip r:embed="rId10"/>
+          <a:stretch>
+            <a:fillRect/>
+          </a:stretch>
+        </p:blipFill>
+        <p:spPr>
+          <a:xfrm>
+            <a:off x="3758576" y="640271"/>
+            <a:ext cx="725740" cy="725740"/>
+          </a:xfrm>
+          <a:prstGeom prst="rect">
+            <a:avLst/>
+          </a:prstGeom>
+        </p:spPr>
+      </p:pic>
+      <p:sp>
+        <p:nvSpPr>
+          <p:cNvPr id="61" name="CuadroTexto 60">
+            <a:extLst>
+              <a:ext uri="{FF2B5EF4-FFF2-40B4-BE49-F238E27FC236}">
+                <a16:creationId xmlns:a16="http://schemas.microsoft.com/office/drawing/2014/main" id="{439565AB-3679-555F-4CDE-4029A48EACE4}"/>
+              </a:ext>
+            </a:extLst>
+          </p:cNvPr>
+          <p:cNvSpPr txBox="1"/>
+          <p:nvPr/>
+        </p:nvSpPr>
+        <p:spPr>
+          <a:xfrm>
+            <a:off x="3516676" y="3142936"/>
+            <a:ext cx="1192277" cy="261610"/>
+          </a:xfrm>
+          <a:prstGeom prst="rect">
+            <a:avLst/>
+          </a:prstGeom>
+          <a:noFill/>
+        </p:spPr>
+        <p:txBody>
+          <a:bodyPr wrap="square">
+            <a:spAutoFit/>
+          </a:bodyPr>
+          <a:lstStyle/>
+          <a:p>
+            <a:pPr marL="0" marR="0" lvl="0" indent="0" algn="ctr" defTabSz="914400" rtl="0" eaLnBrk="1" fontAlgn="auto" latinLnBrk="0" hangingPunct="1">
+              <a:lnSpc>
+                <a:spcPct val="100000"/>
+              </a:lnSpc>
+              <a:spcBef>
+                <a:spcPts val="0"/>
+              </a:spcBef>
+              <a:spcAft>
+                <a:spcPts val="0"/>
+              </a:spcAft>
+              <a:buClrTx/>
+              <a:buSzTx/>
+              <a:buFontTx/>
+              <a:buNone/>
+              <a:tabLst/>
+              <a:defRPr/>
+            </a:pPr>
+            <a:r>
+              <a:rPr kumimoji="0" lang="es-CO" sz="1100" b="1" i="0" u="none" strike="noStrike" kern="1200" cap="none" spc="0" normalizeH="0" baseline="0" noProof="0" dirty="0">
+                <a:ln>
+                  <a:noFill/>
+                </a:ln>
+                <a:solidFill>
+                  <a:srgbClr val="2C2A28"/>
+                </a:solidFill>
+                <a:effectLst/>
+                <a:uLnTx/>
+                <a:uFillTx/>
+                <a:latin typeface="CIBFont Sans Light" panose="020B0603020202020104" pitchFamily="34" charset="0"/>
+                <a:ea typeface="+mn-ea"/>
+                <a:cs typeface="+mn-cs"/>
+              </a:rPr>
+              <a:t>Consultar cliente</a:t>
+            </a:r>
+          </a:p>
+        </p:txBody>
+      </p:sp>
+      <p:sp>
+        <p:nvSpPr>
+          <p:cNvPr id="68" name="CuadroTexto 67">
+            <a:extLst>
+              <a:ext uri="{FF2B5EF4-FFF2-40B4-BE49-F238E27FC236}">
+                <a16:creationId xmlns:a16="http://schemas.microsoft.com/office/drawing/2014/main" id="{05881079-08C1-5F1D-5E6B-2EF46609A8CC}"/>
+              </a:ext>
+            </a:extLst>
+          </p:cNvPr>
+          <p:cNvSpPr txBox="1"/>
+          <p:nvPr/>
+        </p:nvSpPr>
+        <p:spPr>
+          <a:xfrm>
+            <a:off x="5050798" y="3132776"/>
+            <a:ext cx="1192277" cy="430887"/>
+          </a:xfrm>
+          <a:prstGeom prst="rect">
+            <a:avLst/>
+          </a:prstGeom>
+          <a:noFill/>
+        </p:spPr>
+        <p:txBody>
+          <a:bodyPr wrap="square">
+            <a:spAutoFit/>
+          </a:bodyPr>
+          <a:lstStyle/>
+          <a:p>
+            <a:pPr marL="0" marR="0" lvl="0" indent="0" algn="ctr" defTabSz="914400" rtl="0" eaLnBrk="1" fontAlgn="auto" latinLnBrk="0" hangingPunct="1">
+              <a:lnSpc>
+                <a:spcPct val="100000"/>
+              </a:lnSpc>
+              <a:spcBef>
+                <a:spcPts val="0"/>
+              </a:spcBef>
+              <a:spcAft>
+                <a:spcPts val="0"/>
+              </a:spcAft>
+              <a:buClrTx/>
+              <a:buSzTx/>
+              <a:buFontTx/>
+              <a:buNone/>
+              <a:tabLst/>
+              <a:defRPr/>
+            </a:pPr>
+            <a:r>
+              <a:rPr kumimoji="0" lang="es-CO" sz="1100" b="1" i="0" u="none" strike="noStrike" kern="1200" cap="none" spc="0" normalizeH="0" baseline="0" noProof="0" dirty="0">
+                <a:ln>
+                  <a:noFill/>
+                </a:ln>
+                <a:solidFill>
+                  <a:srgbClr val="2C2A28"/>
+                </a:solidFill>
+                <a:effectLst/>
+                <a:uLnTx/>
+                <a:uFillTx/>
+                <a:latin typeface="CIBFont Sans Light" panose="020B0603020202020104" pitchFamily="34" charset="0"/>
+                <a:ea typeface="+mn-ea"/>
+                <a:cs typeface="+mn-cs"/>
+              </a:rPr>
+              <a:t>Estructura información</a:t>
+            </a:r>
+          </a:p>
+        </p:txBody>
+      </p:sp>
+      <p:cxnSp>
+        <p:nvCxnSpPr>
+          <p:cNvPr id="71" name="Conector recto de flecha 70">
+            <a:extLst>
+              <a:ext uri="{FF2B5EF4-FFF2-40B4-BE49-F238E27FC236}">
+                <a16:creationId xmlns:a16="http://schemas.microsoft.com/office/drawing/2014/main" id="{1241463E-32A0-B5C6-315C-C0A605C639DD}"/>
+              </a:ext>
+            </a:extLst>
+          </p:cNvPr>
+          <p:cNvCxnSpPr>
+            <a:stCxn id="51" idx="3"/>
+            <a:endCxn id="19" idx="1"/>
+          </p:cNvCxnSpPr>
+          <p:nvPr/>
+        </p:nvCxnSpPr>
+        <p:spPr>
+          <a:xfrm flipV="1">
+            <a:off x="4532877" y="2712714"/>
+            <a:ext cx="544738" cy="2896"/>
+          </a:xfrm>
+          <a:prstGeom prst="straightConnector1">
+            <a:avLst/>
+          </a:prstGeom>
+          <a:ln>
+            <a:tailEnd type="triangle"/>
+          </a:ln>
+        </p:spPr>
+        <p:style>
+          <a:lnRef idx="2">
+            <a:schemeClr val="dk1"/>
+          </a:lnRef>
+          <a:fillRef idx="0">
+            <a:schemeClr val="dk1"/>
+          </a:fillRef>
+          <a:effectRef idx="1">
+            <a:schemeClr val="dk1"/>
+          </a:effectRef>
+          <a:fontRef idx="minor">
+            <a:schemeClr val="tx1"/>
+          </a:fontRef>
+        </p:style>
+      </p:cxnSp>
+      <p:sp>
+        <p:nvSpPr>
+          <p:cNvPr id="74" name="CuadroTexto 73">
+            <a:extLst>
+              <a:ext uri="{FF2B5EF4-FFF2-40B4-BE49-F238E27FC236}">
+                <a16:creationId xmlns:a16="http://schemas.microsoft.com/office/drawing/2014/main" id="{6D09B716-C13E-B6E5-579C-BFE04583B4C0}"/>
+              </a:ext>
+            </a:extLst>
+          </p:cNvPr>
+          <p:cNvSpPr txBox="1"/>
+          <p:nvPr/>
+        </p:nvSpPr>
+        <p:spPr>
+          <a:xfrm>
+            <a:off x="8071294" y="1739480"/>
+            <a:ext cx="1192277" cy="430887"/>
+          </a:xfrm>
+          <a:prstGeom prst="rect">
+            <a:avLst/>
+          </a:prstGeom>
+          <a:noFill/>
+        </p:spPr>
+        <p:txBody>
+          <a:bodyPr wrap="square">
+            <a:spAutoFit/>
+          </a:bodyPr>
+          <a:lstStyle/>
+          <a:p>
+            <a:pPr marL="0" marR="0" lvl="0" indent="0" algn="ctr" defTabSz="914400" rtl="0" eaLnBrk="1" fontAlgn="auto" latinLnBrk="0" hangingPunct="1">
+              <a:lnSpc>
+                <a:spcPct val="100000"/>
+              </a:lnSpc>
+              <a:spcBef>
+                <a:spcPts val="0"/>
+              </a:spcBef>
+              <a:spcAft>
+                <a:spcPts val="0"/>
+              </a:spcAft>
+              <a:buClrTx/>
+              <a:buSzTx/>
+              <a:buFontTx/>
+              <a:buNone/>
+              <a:tabLst/>
+              <a:defRPr/>
+            </a:pPr>
+            <a:r>
+              <a:rPr kumimoji="0" lang="es-CO" sz="1100" b="1" i="0" u="none" strike="noStrike" kern="1200" cap="none" spc="0" normalizeH="0" baseline="0" noProof="0" dirty="0">
+                <a:ln>
+                  <a:noFill/>
+                </a:ln>
+                <a:solidFill>
+                  <a:srgbClr val="2C2A28"/>
+                </a:solidFill>
+                <a:effectLst/>
+                <a:uLnTx/>
+                <a:uFillTx/>
+                <a:latin typeface="CIBFont Sans Light" panose="020B0603020202020104" pitchFamily="34" charset="0"/>
+                <a:ea typeface="+mn-ea"/>
+                <a:cs typeface="+mn-cs"/>
+              </a:rPr>
+              <a:t>Agente</a:t>
+            </a:r>
+          </a:p>
+          <a:p>
+            <a:pPr marL="0" marR="0" lvl="0" indent="0" algn="ctr" defTabSz="914400" rtl="0" eaLnBrk="1" fontAlgn="auto" latinLnBrk="0" hangingPunct="1">
+              <a:lnSpc>
+                <a:spcPct val="100000"/>
+              </a:lnSpc>
+              <a:spcBef>
+                <a:spcPts val="0"/>
+              </a:spcBef>
+              <a:spcAft>
+                <a:spcPts val="0"/>
+              </a:spcAft>
+              <a:buClrTx/>
+              <a:buSzTx/>
+              <a:buFontTx/>
+              <a:buNone/>
+              <a:tabLst/>
+              <a:defRPr/>
+            </a:pPr>
+            <a:r>
+              <a:rPr kumimoji="0" lang="es-CO" sz="1100" b="1" i="0" u="none" strike="noStrike" kern="1200" cap="none" spc="0" normalizeH="0" baseline="0" noProof="0" dirty="0">
+                <a:ln>
+                  <a:noFill/>
+                </a:ln>
+                <a:solidFill>
+                  <a:srgbClr val="2C2A28"/>
+                </a:solidFill>
+                <a:effectLst/>
+                <a:uLnTx/>
+                <a:uFillTx/>
+                <a:latin typeface="CIBFont Sans Light" panose="020B0603020202020104" pitchFamily="34" charset="0"/>
+                <a:ea typeface="+mn-ea"/>
+                <a:cs typeface="+mn-cs"/>
+              </a:rPr>
+              <a:t>acuerdos</a:t>
+            </a:r>
+          </a:p>
+        </p:txBody>
+      </p:sp>
+      <p:sp>
+        <p:nvSpPr>
+          <p:cNvPr id="77" name="CuadroTexto 76">
+            <a:extLst>
+              <a:ext uri="{FF2B5EF4-FFF2-40B4-BE49-F238E27FC236}">
+                <a16:creationId xmlns:a16="http://schemas.microsoft.com/office/drawing/2014/main" id="{84E0EC76-A8EA-5512-3289-075EFA4B1CDC}"/>
+              </a:ext>
+            </a:extLst>
+          </p:cNvPr>
+          <p:cNvSpPr txBox="1"/>
+          <p:nvPr/>
+        </p:nvSpPr>
+        <p:spPr>
+          <a:xfrm>
+            <a:off x="8052767" y="3171585"/>
+            <a:ext cx="1192277" cy="430887"/>
+          </a:xfrm>
+          <a:prstGeom prst="rect">
+            <a:avLst/>
+          </a:prstGeom>
+          <a:noFill/>
+        </p:spPr>
+        <p:txBody>
+          <a:bodyPr wrap="square">
+            <a:spAutoFit/>
+          </a:bodyPr>
+          <a:lstStyle/>
+          <a:p>
+            <a:pPr marL="0" marR="0" lvl="0" indent="0" algn="ctr" defTabSz="914400" rtl="0" eaLnBrk="1" fontAlgn="auto" latinLnBrk="0" hangingPunct="1">
+              <a:lnSpc>
+                <a:spcPct val="100000"/>
+              </a:lnSpc>
+              <a:spcBef>
+                <a:spcPts val="0"/>
+              </a:spcBef>
+              <a:spcAft>
+                <a:spcPts val="0"/>
+              </a:spcAft>
+              <a:buClrTx/>
+              <a:buSzTx/>
+              <a:buFontTx/>
+              <a:buNone/>
+              <a:tabLst/>
+              <a:defRPr/>
+            </a:pPr>
+            <a:r>
+              <a:rPr kumimoji="0" lang="es-CO" sz="1100" b="1" i="0" u="none" strike="noStrike" kern="1200" cap="none" spc="0" normalizeH="0" baseline="0" noProof="0" dirty="0">
+                <a:ln>
+                  <a:noFill/>
+                </a:ln>
+                <a:solidFill>
+                  <a:srgbClr val="2C2A28"/>
+                </a:solidFill>
+                <a:effectLst/>
+                <a:uLnTx/>
+                <a:uFillTx/>
+                <a:latin typeface="CIBFont Sans Light" panose="020B0603020202020104" pitchFamily="34" charset="0"/>
+                <a:ea typeface="+mn-ea"/>
+                <a:cs typeface="+mn-cs"/>
+              </a:rPr>
+              <a:t>Agente </a:t>
+            </a:r>
+          </a:p>
+          <a:p>
+            <a:pPr marL="0" marR="0" lvl="0" indent="0" algn="ctr" defTabSz="914400" rtl="0" eaLnBrk="1" fontAlgn="auto" latinLnBrk="0" hangingPunct="1">
+              <a:lnSpc>
+                <a:spcPct val="100000"/>
+              </a:lnSpc>
+              <a:spcBef>
+                <a:spcPts val="0"/>
+              </a:spcBef>
+              <a:spcAft>
+                <a:spcPts val="0"/>
+              </a:spcAft>
+              <a:buClrTx/>
+              <a:buSzTx/>
+              <a:buFontTx/>
+              <a:buNone/>
+              <a:tabLst/>
+              <a:defRPr/>
+            </a:pPr>
+            <a:r>
+              <a:rPr kumimoji="0" lang="es-CO" sz="1100" b="1" i="0" u="none" strike="noStrike" kern="1200" cap="none" spc="0" normalizeH="0" baseline="0" noProof="0" dirty="0">
+                <a:ln>
+                  <a:noFill/>
+                </a:ln>
+                <a:solidFill>
+                  <a:srgbClr val="2C2A28"/>
+                </a:solidFill>
+                <a:effectLst/>
+                <a:uLnTx/>
+                <a:uFillTx/>
+                <a:latin typeface="CIBFont Sans Light" panose="020B0603020202020104" pitchFamily="34" charset="0"/>
+                <a:ea typeface="+mn-ea"/>
+                <a:cs typeface="+mn-cs"/>
+              </a:rPr>
+              <a:t>opciones</a:t>
+            </a:r>
+          </a:p>
+        </p:txBody>
+      </p:sp>
+      <p:cxnSp>
+        <p:nvCxnSpPr>
+          <p:cNvPr id="78" name="Conector recto de flecha 77">
+            <a:extLst>
+              <a:ext uri="{FF2B5EF4-FFF2-40B4-BE49-F238E27FC236}">
+                <a16:creationId xmlns:a16="http://schemas.microsoft.com/office/drawing/2014/main" id="{481A9ADF-740A-6A4C-D0C5-0C9172B9C43B}"/>
+              </a:ext>
+            </a:extLst>
+          </p:cNvPr>
+          <p:cNvCxnSpPr>
+            <a:cxnSpLocks/>
+            <a:stCxn id="19" idx="3"/>
+            <a:endCxn id="37" idx="1"/>
+          </p:cNvCxnSpPr>
+          <p:nvPr/>
+        </p:nvCxnSpPr>
+        <p:spPr>
+          <a:xfrm>
+            <a:off x="6003179" y="2712714"/>
+            <a:ext cx="537895" cy="0"/>
+          </a:xfrm>
+          <a:prstGeom prst="straightConnector1">
+            <a:avLst/>
+          </a:prstGeom>
+          <a:ln>
+            <a:tailEnd type="triangle"/>
+          </a:ln>
+        </p:spPr>
+        <p:style>
+          <a:lnRef idx="2">
+            <a:schemeClr val="dk1"/>
+          </a:lnRef>
+          <a:fillRef idx="0">
+            <a:schemeClr val="dk1"/>
+          </a:fillRef>
+          <a:effectRef idx="1">
+            <a:schemeClr val="dk1"/>
+          </a:effectRef>
+          <a:fontRef idx="minor">
+            <a:schemeClr val="tx1"/>
+          </a:fontRef>
+        </p:style>
+      </p:cxnSp>
+      <p:sp>
+        <p:nvSpPr>
+          <p:cNvPr id="83" name="CuadroTexto 82">
+            <a:extLst>
+              <a:ext uri="{FF2B5EF4-FFF2-40B4-BE49-F238E27FC236}">
+                <a16:creationId xmlns:a16="http://schemas.microsoft.com/office/drawing/2014/main" id="{64C5DB11-65FE-6DC3-4CCD-8E91045C725B}"/>
+              </a:ext>
+            </a:extLst>
+          </p:cNvPr>
+          <p:cNvSpPr txBox="1"/>
+          <p:nvPr/>
+        </p:nvSpPr>
+        <p:spPr>
+          <a:xfrm>
+            <a:off x="3546999" y="5045604"/>
+            <a:ext cx="1192277" cy="261610"/>
+          </a:xfrm>
+          <a:prstGeom prst="rect">
+            <a:avLst/>
+          </a:prstGeom>
+          <a:noFill/>
+        </p:spPr>
+        <p:txBody>
+          <a:bodyPr wrap="square">
+            <a:spAutoFit/>
+          </a:bodyPr>
+          <a:lstStyle/>
+          <a:p>
+            <a:pPr marL="0" marR="0" lvl="0" indent="0" algn="ctr" defTabSz="914400" rtl="0" eaLnBrk="1" fontAlgn="auto" latinLnBrk="0" hangingPunct="1">
+              <a:lnSpc>
+                <a:spcPct val="100000"/>
+              </a:lnSpc>
+              <a:spcBef>
+                <a:spcPts val="0"/>
+              </a:spcBef>
+              <a:spcAft>
+                <a:spcPts val="0"/>
+              </a:spcAft>
+              <a:buClrTx/>
+              <a:buSzTx/>
+              <a:buFontTx/>
+              <a:buNone/>
+              <a:tabLst/>
+              <a:defRPr/>
+            </a:pPr>
+            <a:r>
+              <a:rPr kumimoji="0" lang="es-CO" sz="1100" b="1" i="0" u="none" strike="noStrike" kern="1200" cap="none" spc="0" normalizeH="0" baseline="0" noProof="0" dirty="0">
+                <a:ln>
+                  <a:noFill/>
+                </a:ln>
+                <a:solidFill>
+                  <a:srgbClr val="2C2A28"/>
+                </a:solidFill>
+                <a:effectLst/>
+                <a:uLnTx/>
+                <a:uFillTx/>
+                <a:latin typeface="CIBFont Sans Light" panose="020B0603020202020104" pitchFamily="34" charset="0"/>
+                <a:ea typeface="+mn-ea"/>
+                <a:cs typeface="+mn-cs"/>
+              </a:rPr>
+              <a:t>Bot</a:t>
+            </a:r>
+          </a:p>
+        </p:txBody>
+      </p:sp>
+      <p:sp>
+        <p:nvSpPr>
+          <p:cNvPr id="88" name="CuadroTexto 87">
+            <a:extLst>
+              <a:ext uri="{FF2B5EF4-FFF2-40B4-BE49-F238E27FC236}">
+                <a16:creationId xmlns:a16="http://schemas.microsoft.com/office/drawing/2014/main" id="{081BA4D2-BE2F-D209-1373-BC8CBE715771}"/>
+              </a:ext>
+            </a:extLst>
+          </p:cNvPr>
+          <p:cNvSpPr txBox="1"/>
+          <p:nvPr/>
+        </p:nvSpPr>
+        <p:spPr>
+          <a:xfrm>
+            <a:off x="3443514" y="1301060"/>
+            <a:ext cx="1399248" cy="430887"/>
+          </a:xfrm>
+          <a:prstGeom prst="rect">
+            <a:avLst/>
+          </a:prstGeom>
+          <a:noFill/>
+        </p:spPr>
+        <p:txBody>
+          <a:bodyPr wrap="square">
+            <a:spAutoFit/>
+          </a:bodyPr>
+          <a:lstStyle/>
+          <a:p>
+            <a:pPr marL="0" marR="0" lvl="0" indent="0" algn="ctr" defTabSz="914400" rtl="0" eaLnBrk="1" fontAlgn="auto" latinLnBrk="0" hangingPunct="1">
+              <a:lnSpc>
+                <a:spcPct val="100000"/>
+              </a:lnSpc>
+              <a:spcBef>
+                <a:spcPts val="0"/>
+              </a:spcBef>
+              <a:spcAft>
+                <a:spcPts val="0"/>
+              </a:spcAft>
+              <a:buClrTx/>
+              <a:buSzTx/>
+              <a:buFontTx/>
+              <a:buNone/>
+              <a:tabLst/>
+              <a:defRPr/>
+            </a:pPr>
+            <a:r>
+              <a:rPr kumimoji="0" lang="es-CO" sz="1100" b="1" i="0" u="none" strike="noStrike" kern="1200" cap="none" spc="0" normalizeH="0" baseline="0" noProof="0" dirty="0">
+                <a:ln>
+                  <a:noFill/>
+                </a:ln>
+                <a:solidFill>
+                  <a:srgbClr val="2C2A28"/>
+                </a:solidFill>
+                <a:effectLst/>
+                <a:uLnTx/>
+                <a:uFillTx/>
+                <a:latin typeface="CIBFont Sans Light" panose="020B0603020202020104" pitchFamily="34" charset="0"/>
+                <a:ea typeface="+mn-ea"/>
+                <a:cs typeface="+mn-cs"/>
+              </a:rPr>
+              <a:t>Ejecución proceso automático</a:t>
+            </a:r>
+          </a:p>
+        </p:txBody>
+      </p:sp>
+      <p:cxnSp>
+        <p:nvCxnSpPr>
+          <p:cNvPr id="89" name="Conector recto de flecha 88">
+            <a:extLst>
+              <a:ext uri="{FF2B5EF4-FFF2-40B4-BE49-F238E27FC236}">
+                <a16:creationId xmlns:a16="http://schemas.microsoft.com/office/drawing/2014/main" id="{EF4E0516-A44A-BCAF-8682-ECB22C2F8EFA}"/>
+              </a:ext>
+            </a:extLst>
+          </p:cNvPr>
+          <p:cNvCxnSpPr>
+            <a:cxnSpLocks/>
+            <a:endCxn id="61" idx="2"/>
+          </p:cNvCxnSpPr>
+          <p:nvPr/>
+        </p:nvCxnSpPr>
+        <p:spPr>
+          <a:xfrm flipV="1">
+            <a:off x="4112815" y="3404546"/>
+            <a:ext cx="0" cy="609873"/>
+          </a:xfrm>
+          <a:prstGeom prst="straightConnector1">
+            <a:avLst/>
+          </a:prstGeom>
+          <a:ln>
+            <a:tailEnd type="triangle"/>
+          </a:ln>
+        </p:spPr>
+        <p:style>
+          <a:lnRef idx="2">
+            <a:schemeClr val="dk1"/>
+          </a:lnRef>
+          <a:fillRef idx="0">
+            <a:schemeClr val="dk1"/>
+          </a:fillRef>
+          <a:effectRef idx="1">
+            <a:schemeClr val="dk1"/>
+          </a:effectRef>
+          <a:fontRef idx="minor">
+            <a:schemeClr val="tx1"/>
+          </a:fontRef>
+        </p:style>
+      </p:cxnSp>
+      <p:cxnSp>
+        <p:nvCxnSpPr>
+          <p:cNvPr id="94" name="Conector recto de flecha 93">
+            <a:extLst>
+              <a:ext uri="{FF2B5EF4-FFF2-40B4-BE49-F238E27FC236}">
+                <a16:creationId xmlns:a16="http://schemas.microsoft.com/office/drawing/2014/main" id="{AA15607C-5ADA-69BE-E8DC-F55ECB380757}"/>
+              </a:ext>
+            </a:extLst>
+          </p:cNvPr>
+          <p:cNvCxnSpPr>
+            <a:cxnSpLocks/>
+            <a:stCxn id="14" idx="3"/>
+            <a:endCxn id="53" idx="1"/>
+          </p:cNvCxnSpPr>
+          <p:nvPr/>
+        </p:nvCxnSpPr>
+        <p:spPr>
+          <a:xfrm>
+            <a:off x="3209971" y="4544766"/>
+            <a:ext cx="540411" cy="0"/>
+          </a:xfrm>
+          <a:prstGeom prst="straightConnector1">
+            <a:avLst/>
+          </a:prstGeom>
+          <a:ln>
+            <a:tailEnd type="triangle"/>
+          </a:ln>
+        </p:spPr>
+        <p:style>
+          <a:lnRef idx="2">
+            <a:schemeClr val="dk1"/>
+          </a:lnRef>
+          <a:fillRef idx="0">
+            <a:schemeClr val="dk1"/>
+          </a:fillRef>
+          <a:effectRef idx="1">
+            <a:schemeClr val="dk1"/>
+          </a:effectRef>
+          <a:fontRef idx="minor">
+            <a:schemeClr val="tx1"/>
+          </a:fontRef>
+        </p:style>
+      </p:cxnSp>
+      <p:cxnSp>
+        <p:nvCxnSpPr>
+          <p:cNvPr id="103" name="Conector: angular 102">
+            <a:extLst>
+              <a:ext uri="{FF2B5EF4-FFF2-40B4-BE49-F238E27FC236}">
+                <a16:creationId xmlns:a16="http://schemas.microsoft.com/office/drawing/2014/main" id="{E7C884C8-4E4B-FF38-9351-64D96213932A}"/>
+              </a:ext>
+            </a:extLst>
+          </p:cNvPr>
+          <p:cNvCxnSpPr>
+            <a:stCxn id="37" idx="3"/>
+            <a:endCxn id="22" idx="1"/>
+          </p:cNvCxnSpPr>
+          <p:nvPr/>
+        </p:nvCxnSpPr>
+        <p:spPr>
+          <a:xfrm flipV="1">
+            <a:off x="7484594" y="1276698"/>
+            <a:ext cx="720057" cy="1436016"/>
+          </a:xfrm>
+          <a:prstGeom prst="bentConnector3">
+            <a:avLst/>
+          </a:prstGeom>
+          <a:ln>
+            <a:tailEnd type="triangle"/>
+          </a:ln>
+        </p:spPr>
+        <p:style>
+          <a:lnRef idx="2">
+            <a:schemeClr val="dk1"/>
+          </a:lnRef>
+          <a:fillRef idx="0">
+            <a:schemeClr val="dk1"/>
+          </a:fillRef>
+          <a:effectRef idx="1">
+            <a:schemeClr val="dk1"/>
+          </a:effectRef>
+          <a:fontRef idx="minor">
+            <a:schemeClr val="tx1"/>
+          </a:fontRef>
+        </p:style>
+      </p:cxnSp>
+      <p:cxnSp>
+        <p:nvCxnSpPr>
+          <p:cNvPr id="104" name="Conector recto de flecha 103">
+            <a:extLst>
+              <a:ext uri="{FF2B5EF4-FFF2-40B4-BE49-F238E27FC236}">
+                <a16:creationId xmlns:a16="http://schemas.microsoft.com/office/drawing/2014/main" id="{A7183B9B-6280-A77E-4651-AF140F626540}"/>
+              </a:ext>
+            </a:extLst>
+          </p:cNvPr>
+          <p:cNvCxnSpPr>
+            <a:cxnSpLocks/>
+            <a:stCxn id="37" idx="3"/>
+            <a:endCxn id="41" idx="1"/>
+          </p:cNvCxnSpPr>
+          <p:nvPr/>
+        </p:nvCxnSpPr>
+        <p:spPr>
+          <a:xfrm>
+            <a:off x="7484594" y="2712714"/>
+            <a:ext cx="696588" cy="3911"/>
+          </a:xfrm>
+          <a:prstGeom prst="straightConnector1">
+            <a:avLst/>
+          </a:prstGeom>
+          <a:ln>
+            <a:tailEnd type="triangle"/>
+          </a:ln>
+        </p:spPr>
+        <p:style>
+          <a:lnRef idx="2">
+            <a:schemeClr val="dk1"/>
+          </a:lnRef>
+          <a:fillRef idx="0">
+            <a:schemeClr val="dk1"/>
+          </a:fillRef>
+          <a:effectRef idx="1">
+            <a:schemeClr val="dk1"/>
+          </a:effectRef>
+          <a:fontRef idx="minor">
+            <a:schemeClr val="tx1"/>
+          </a:fontRef>
+        </p:style>
+      </p:cxnSp>
+      <p:sp>
+        <p:nvSpPr>
+          <p:cNvPr id="115" name="CuadroTexto 114">
+            <a:extLst>
+              <a:ext uri="{FF2B5EF4-FFF2-40B4-BE49-F238E27FC236}">
+                <a16:creationId xmlns:a16="http://schemas.microsoft.com/office/drawing/2014/main" id="{C5D8F809-FC11-4BDB-E030-AC8F24FB5ACD}"/>
+              </a:ext>
+            </a:extLst>
+          </p:cNvPr>
+          <p:cNvSpPr txBox="1"/>
+          <p:nvPr/>
+        </p:nvSpPr>
+        <p:spPr>
+          <a:xfrm>
+            <a:off x="8092558" y="4529985"/>
+            <a:ext cx="1192277" cy="430887"/>
+          </a:xfrm>
+          <a:prstGeom prst="rect">
+            <a:avLst/>
+          </a:prstGeom>
+          <a:noFill/>
+        </p:spPr>
+        <p:txBody>
+          <a:bodyPr wrap="square">
+            <a:spAutoFit/>
+          </a:bodyPr>
+          <a:lstStyle/>
+          <a:p>
+            <a:pPr marL="0" marR="0" lvl="0" indent="0" algn="ctr" defTabSz="914400" rtl="0" eaLnBrk="1" fontAlgn="auto" latinLnBrk="0" hangingPunct="1">
+              <a:lnSpc>
+                <a:spcPct val="100000"/>
+              </a:lnSpc>
+              <a:spcBef>
+                <a:spcPts val="0"/>
+              </a:spcBef>
+              <a:spcAft>
+                <a:spcPts val="0"/>
+              </a:spcAft>
+              <a:buClrTx/>
+              <a:buSzTx/>
+              <a:buFontTx/>
+              <a:buNone/>
+              <a:tabLst/>
+              <a:defRPr/>
+            </a:pPr>
+            <a:r>
+              <a:rPr kumimoji="0" lang="es-CO" sz="1100" b="1" i="0" u="none" strike="noStrike" kern="1200" cap="none" spc="0" normalizeH="0" baseline="0" noProof="0" dirty="0">
+                <a:ln>
+                  <a:noFill/>
+                </a:ln>
+                <a:solidFill>
+                  <a:srgbClr val="2C2A28"/>
+                </a:solidFill>
+                <a:effectLst/>
+                <a:uLnTx/>
+                <a:uFillTx/>
+                <a:latin typeface="CIBFont Sans Light" panose="020B0603020202020104" pitchFamily="34" charset="0"/>
+                <a:ea typeface="+mn-ea"/>
+                <a:cs typeface="+mn-cs"/>
+              </a:rPr>
+              <a:t>Agente castigada</a:t>
+            </a:r>
+          </a:p>
+        </p:txBody>
+      </p:sp>
+      <p:cxnSp>
+        <p:nvCxnSpPr>
+          <p:cNvPr id="116" name="Conector: angular 115">
+            <a:extLst>
+              <a:ext uri="{FF2B5EF4-FFF2-40B4-BE49-F238E27FC236}">
+                <a16:creationId xmlns:a16="http://schemas.microsoft.com/office/drawing/2014/main" id="{9B6B72E2-82BC-3EE5-ED2F-FA56AA7AA739}"/>
+              </a:ext>
+            </a:extLst>
+          </p:cNvPr>
+          <p:cNvCxnSpPr>
+            <a:cxnSpLocks/>
+            <a:stCxn id="37" idx="3"/>
+            <a:endCxn id="45" idx="1"/>
+          </p:cNvCxnSpPr>
+          <p:nvPr/>
+        </p:nvCxnSpPr>
+        <p:spPr>
+          <a:xfrm>
+            <a:off x="7484594" y="2712714"/>
+            <a:ext cx="717852" cy="1379825"/>
+          </a:xfrm>
+          <a:prstGeom prst="bentConnector3">
+            <a:avLst>
+              <a:gd name="adj1" fmla="val 50000"/>
+            </a:avLst>
+          </a:prstGeom>
+          <a:ln>
+            <a:tailEnd type="triangle"/>
+          </a:ln>
+        </p:spPr>
+        <p:style>
+          <a:lnRef idx="2">
+            <a:schemeClr val="dk1"/>
+          </a:lnRef>
+          <a:fillRef idx="0">
+            <a:schemeClr val="dk1"/>
+          </a:fillRef>
+          <a:effectRef idx="1">
+            <a:schemeClr val="dk1"/>
+          </a:effectRef>
+          <a:fontRef idx="minor">
+            <a:schemeClr val="tx1"/>
+          </a:fontRef>
+        </p:style>
+      </p:cxnSp>
+      <p:sp>
+        <p:nvSpPr>
+          <p:cNvPr id="119" name="Rectángulo 118">
+            <a:extLst>
+              <a:ext uri="{FF2B5EF4-FFF2-40B4-BE49-F238E27FC236}">
+                <a16:creationId xmlns:a16="http://schemas.microsoft.com/office/drawing/2014/main" id="{268411AC-4449-DC29-500D-B93E7D8ECD3A}"/>
+              </a:ext>
+            </a:extLst>
+          </p:cNvPr>
+          <p:cNvSpPr/>
+          <p:nvPr/>
+        </p:nvSpPr>
+        <p:spPr>
+          <a:xfrm>
+            <a:off x="2265013" y="3936329"/>
+            <a:ext cx="2443939" cy="1374798"/>
+          </a:xfrm>
+          <a:prstGeom prst="rect">
+            <a:avLst/>
+          </a:prstGeom>
+          <a:noFill/>
+          <a:ln>
+            <a:solidFill>
+              <a:schemeClr val="accent2"/>
+            </a:solidFill>
+            <a:prstDash val="dash"/>
+          </a:ln>
+        </p:spPr>
+        <p:style>
+          <a:lnRef idx="2">
+            <a:schemeClr val="accent1">
+              <a:shade val="15000"/>
+            </a:schemeClr>
+          </a:lnRef>
+          <a:fillRef idx="1">
+            <a:schemeClr val="accent1"/>
+          </a:fillRef>
+          <a:effectRef idx="0">
+            <a:schemeClr val="accent1"/>
+          </a:effectRef>
+          <a:fontRef idx="minor">
+            <a:schemeClr val="lt1"/>
+          </a:fontRef>
+        </p:style>
+        <p:txBody>
+          <a:bodyPr rtlCol="0" anchor="ctr"/>
+          <a:lstStyle/>
+          <a:p>
+            <a:pPr algn="ctr"/>
+            <a:endParaRPr lang="es-CO"/>
+          </a:p>
+        </p:txBody>
+      </p:sp>
+      <p:sp>
+        <p:nvSpPr>
+          <p:cNvPr id="122" name="CuadroTexto 121">
+            <a:extLst>
+              <a:ext uri="{FF2B5EF4-FFF2-40B4-BE49-F238E27FC236}">
+                <a16:creationId xmlns:a16="http://schemas.microsoft.com/office/drawing/2014/main" id="{0EBBB547-3442-EFC1-E8F2-18BE860A0116}"/>
+              </a:ext>
+            </a:extLst>
+          </p:cNvPr>
+          <p:cNvSpPr txBox="1"/>
+          <p:nvPr/>
+        </p:nvSpPr>
+        <p:spPr>
+          <a:xfrm>
+            <a:off x="2918257" y="5356607"/>
+            <a:ext cx="1192277" cy="430887"/>
+          </a:xfrm>
+          <a:prstGeom prst="rect">
+            <a:avLst/>
+          </a:prstGeom>
+          <a:noFill/>
+        </p:spPr>
+        <p:txBody>
+          <a:bodyPr wrap="square">
+            <a:spAutoFit/>
+          </a:bodyPr>
+          <a:lstStyle/>
+          <a:p>
+            <a:pPr marL="0" marR="0" lvl="0" indent="0" algn="ctr" defTabSz="914400" rtl="0" eaLnBrk="1" fontAlgn="auto" latinLnBrk="0" hangingPunct="1">
+              <a:lnSpc>
+                <a:spcPct val="100000"/>
+              </a:lnSpc>
+              <a:spcBef>
+                <a:spcPts val="0"/>
+              </a:spcBef>
+              <a:spcAft>
+                <a:spcPts val="0"/>
+              </a:spcAft>
+              <a:buClrTx/>
+              <a:buSzTx/>
+              <a:buFontTx/>
+              <a:buNone/>
+              <a:tabLst/>
+              <a:defRPr/>
+            </a:pPr>
+            <a:r>
+              <a:rPr kumimoji="0" lang="es-CO" sz="1100" b="1" i="0" u="none" strike="noStrike" kern="1200" cap="none" spc="0" normalizeH="0" baseline="0" noProof="0" dirty="0">
+                <a:ln>
+                  <a:noFill/>
+                </a:ln>
+                <a:solidFill>
+                  <a:srgbClr val="2C2A28"/>
+                </a:solidFill>
+                <a:effectLst/>
+                <a:uLnTx/>
+                <a:uFillTx/>
+                <a:latin typeface="CIBFont Sans Light" panose="020B0603020202020104" pitchFamily="34" charset="0"/>
+                <a:ea typeface="+mn-ea"/>
+                <a:cs typeface="+mn-cs"/>
+              </a:rPr>
+              <a:t>Contacto reactivo </a:t>
+            </a:r>
+          </a:p>
+        </p:txBody>
+      </p:sp>
+      <p:pic>
+        <p:nvPicPr>
+          <p:cNvPr id="127" name="Imagen 126">
+            <a:extLst>
+              <a:ext uri="{FF2B5EF4-FFF2-40B4-BE49-F238E27FC236}">
+                <a16:creationId xmlns:a16="http://schemas.microsoft.com/office/drawing/2014/main" id="{15CDA326-F9A8-92C9-94C9-55A0C3C22BAA}"/>
+              </a:ext>
+            </a:extLst>
+          </p:cNvPr>
+          <p:cNvPicPr>
+            <a:picLocks noChangeAspect="1"/>
+          </p:cNvPicPr>
+          <p:nvPr/>
+        </p:nvPicPr>
+        <p:blipFill>
+          <a:blip r:embed="rId11"/>
+          <a:stretch>
+            <a:fillRect/>
+          </a:stretch>
+        </p:blipFill>
+        <p:spPr>
+          <a:xfrm>
+            <a:off x="10082732" y="2455118"/>
+            <a:ext cx="773640" cy="773640"/>
+          </a:xfrm>
+          <a:prstGeom prst="rect">
+            <a:avLst/>
+          </a:prstGeom>
+        </p:spPr>
+      </p:pic>
+      <p:sp>
+        <p:nvSpPr>
+          <p:cNvPr id="129" name="Rectángulo 128">
+            <a:extLst>
+              <a:ext uri="{FF2B5EF4-FFF2-40B4-BE49-F238E27FC236}">
+                <a16:creationId xmlns:a16="http://schemas.microsoft.com/office/drawing/2014/main" id="{9EDDCDD4-7F1B-8633-1E6A-E32F8B98ABE6}"/>
+              </a:ext>
+            </a:extLst>
+          </p:cNvPr>
+          <p:cNvSpPr/>
+          <p:nvPr/>
+        </p:nvSpPr>
+        <p:spPr>
+          <a:xfrm>
+            <a:off x="7659264" y="640271"/>
+            <a:ext cx="1835889" cy="4405333"/>
+          </a:xfrm>
+          <a:prstGeom prst="rect">
+            <a:avLst/>
+          </a:prstGeom>
+          <a:noFill/>
+          <a:ln>
+            <a:solidFill>
+              <a:srgbClr val="473080"/>
+            </a:solidFill>
+            <a:prstDash val="dash"/>
+          </a:ln>
+        </p:spPr>
+        <p:style>
+          <a:lnRef idx="2">
+            <a:schemeClr val="accent1">
+              <a:shade val="15000"/>
+            </a:schemeClr>
+          </a:lnRef>
+          <a:fillRef idx="1">
+            <a:schemeClr val="accent1"/>
+          </a:fillRef>
+          <a:effectRef idx="0">
+            <a:schemeClr val="accent1"/>
+          </a:effectRef>
+          <a:fontRef idx="minor">
+            <a:schemeClr val="lt1"/>
+          </a:fontRef>
+        </p:style>
+        <p:txBody>
+          <a:bodyPr rtlCol="0" anchor="ctr"/>
+          <a:lstStyle/>
+          <a:p>
+            <a:pPr algn="ctr"/>
+            <a:endParaRPr lang="es-CO"/>
+          </a:p>
+        </p:txBody>
+      </p:sp>
+      <p:sp>
+        <p:nvSpPr>
+          <p:cNvPr id="132" name="Rectángulo 131">
+            <a:extLst>
+              <a:ext uri="{FF2B5EF4-FFF2-40B4-BE49-F238E27FC236}">
+                <a16:creationId xmlns:a16="http://schemas.microsoft.com/office/drawing/2014/main" id="{AEC3B808-61A4-D983-DA3A-1FB214847211}"/>
+              </a:ext>
+            </a:extLst>
+          </p:cNvPr>
+          <p:cNvSpPr/>
+          <p:nvPr/>
+        </p:nvSpPr>
+        <p:spPr>
+          <a:xfrm>
+            <a:off x="3443514" y="526513"/>
+            <a:ext cx="1335036" cy="1254600"/>
+          </a:xfrm>
+          <a:prstGeom prst="rect">
+            <a:avLst/>
+          </a:prstGeom>
+          <a:noFill/>
+          <a:ln>
+            <a:solidFill>
+              <a:schemeClr val="accent6"/>
+            </a:solidFill>
+            <a:prstDash val="dash"/>
+          </a:ln>
+        </p:spPr>
+        <p:style>
+          <a:lnRef idx="2">
+            <a:schemeClr val="accent1">
+              <a:shade val="15000"/>
+            </a:schemeClr>
+          </a:lnRef>
+          <a:fillRef idx="1">
+            <a:schemeClr val="accent1"/>
+          </a:fillRef>
+          <a:effectRef idx="0">
+            <a:schemeClr val="accent1"/>
+          </a:effectRef>
+          <a:fontRef idx="minor">
+            <a:schemeClr val="lt1"/>
+          </a:fontRef>
+        </p:style>
+        <p:txBody>
+          <a:bodyPr rtlCol="0" anchor="ctr"/>
+          <a:lstStyle/>
+          <a:p>
+            <a:pPr algn="ctr"/>
+            <a:endParaRPr lang="es-CO"/>
+          </a:p>
+        </p:txBody>
+      </p:sp>
+      <p:sp>
+        <p:nvSpPr>
+          <p:cNvPr id="134" name="CuadroTexto 133">
+            <a:extLst>
+              <a:ext uri="{FF2B5EF4-FFF2-40B4-BE49-F238E27FC236}">
+                <a16:creationId xmlns:a16="http://schemas.microsoft.com/office/drawing/2014/main" id="{54810EEB-A332-DCCA-6D76-1C1E03905404}"/>
+              </a:ext>
+            </a:extLst>
+          </p:cNvPr>
+          <p:cNvSpPr txBox="1"/>
+          <p:nvPr/>
+        </p:nvSpPr>
+        <p:spPr>
+          <a:xfrm>
+            <a:off x="3525308" y="86673"/>
+            <a:ext cx="1192277" cy="430887"/>
+          </a:xfrm>
+          <a:prstGeom prst="rect">
+            <a:avLst/>
+          </a:prstGeom>
+          <a:noFill/>
+        </p:spPr>
+        <p:txBody>
+          <a:bodyPr wrap="square">
+            <a:spAutoFit/>
+          </a:bodyPr>
+          <a:lstStyle/>
+          <a:p>
+            <a:pPr marL="0" marR="0" lvl="0" indent="0" algn="ctr" defTabSz="914400" rtl="0" eaLnBrk="1" fontAlgn="auto" latinLnBrk="0" hangingPunct="1">
+              <a:lnSpc>
+                <a:spcPct val="100000"/>
+              </a:lnSpc>
+              <a:spcBef>
+                <a:spcPts val="0"/>
+              </a:spcBef>
+              <a:spcAft>
+                <a:spcPts val="0"/>
+              </a:spcAft>
+              <a:buClrTx/>
+              <a:buSzTx/>
+              <a:buFontTx/>
+              <a:buNone/>
+              <a:tabLst/>
+              <a:defRPr/>
+            </a:pPr>
+            <a:r>
+              <a:rPr kumimoji="0" lang="es-CO" sz="1100" b="1" i="0" u="none" strike="noStrike" kern="1200" cap="none" spc="0" normalizeH="0" baseline="0" noProof="0" dirty="0">
+                <a:ln>
+                  <a:noFill/>
+                </a:ln>
+                <a:solidFill>
+                  <a:srgbClr val="2C2A28"/>
+                </a:solidFill>
+                <a:effectLst/>
+                <a:uLnTx/>
+                <a:uFillTx/>
+                <a:latin typeface="CIBFont Sans Light" panose="020B0603020202020104" pitchFamily="34" charset="0"/>
+                <a:ea typeface="+mn-ea"/>
+                <a:cs typeface="+mn-cs"/>
+              </a:rPr>
+              <a:t>Contacto proactivo</a:t>
+            </a:r>
+          </a:p>
+        </p:txBody>
+      </p:sp>
+      <p:cxnSp>
+        <p:nvCxnSpPr>
+          <p:cNvPr id="137" name="Conector recto de flecha 136">
+            <a:extLst>
+              <a:ext uri="{FF2B5EF4-FFF2-40B4-BE49-F238E27FC236}">
+                <a16:creationId xmlns:a16="http://schemas.microsoft.com/office/drawing/2014/main" id="{BF9401A2-37C3-71DE-08F4-E5EAD307ABDE}"/>
+              </a:ext>
+            </a:extLst>
+          </p:cNvPr>
+          <p:cNvCxnSpPr>
+            <a:cxnSpLocks/>
+            <a:stCxn id="132" idx="2"/>
+            <a:endCxn id="51" idx="0"/>
+          </p:cNvCxnSpPr>
+          <p:nvPr/>
+        </p:nvCxnSpPr>
+        <p:spPr>
+          <a:xfrm>
+            <a:off x="4111032" y="1781113"/>
+            <a:ext cx="1783" cy="514435"/>
+          </a:xfrm>
+          <a:prstGeom prst="straightConnector1">
+            <a:avLst/>
+          </a:prstGeom>
+          <a:ln>
+            <a:tailEnd type="triangle"/>
+          </a:ln>
+        </p:spPr>
+        <p:style>
+          <a:lnRef idx="2">
+            <a:schemeClr val="dk1"/>
+          </a:lnRef>
+          <a:fillRef idx="0">
+            <a:schemeClr val="dk1"/>
+          </a:fillRef>
+          <a:effectRef idx="1">
+            <a:schemeClr val="dk1"/>
+          </a:effectRef>
+          <a:fontRef idx="minor">
+            <a:schemeClr val="tx1"/>
+          </a:fontRef>
+        </p:style>
+      </p:cxnSp>
+      <p:sp>
+        <p:nvSpPr>
+          <p:cNvPr id="142" name="CuadroTexto 141">
+            <a:extLst>
+              <a:ext uri="{FF2B5EF4-FFF2-40B4-BE49-F238E27FC236}">
+                <a16:creationId xmlns:a16="http://schemas.microsoft.com/office/drawing/2014/main" id="{155BBFA4-0AE2-A9EA-7424-CC3E3183AC2C}"/>
+              </a:ext>
+            </a:extLst>
+          </p:cNvPr>
+          <p:cNvSpPr txBox="1"/>
+          <p:nvPr/>
+        </p:nvSpPr>
+        <p:spPr>
+          <a:xfrm>
+            <a:off x="6415133" y="3225347"/>
+            <a:ext cx="1192277" cy="430887"/>
+          </a:xfrm>
+          <a:prstGeom prst="rect">
+            <a:avLst/>
+          </a:prstGeom>
+          <a:noFill/>
+        </p:spPr>
+        <p:txBody>
+          <a:bodyPr wrap="square">
+            <a:spAutoFit/>
+          </a:bodyPr>
+          <a:lstStyle/>
+          <a:p>
+            <a:pPr marL="0" marR="0" lvl="0" indent="0" algn="ctr" defTabSz="914400" rtl="0" eaLnBrk="1" fontAlgn="auto" latinLnBrk="0" hangingPunct="1">
+              <a:lnSpc>
+                <a:spcPct val="100000"/>
+              </a:lnSpc>
+              <a:spcBef>
+                <a:spcPts val="0"/>
+              </a:spcBef>
+              <a:spcAft>
+                <a:spcPts val="0"/>
+              </a:spcAft>
+              <a:buClrTx/>
+              <a:buSzTx/>
+              <a:buFontTx/>
+              <a:buNone/>
+              <a:tabLst/>
+              <a:defRPr/>
+            </a:pPr>
+            <a:r>
+              <a:rPr kumimoji="0" lang="es-CO" sz="1100" b="1" i="0" u="none" strike="noStrike" kern="1200" cap="none" spc="0" normalizeH="0" baseline="0" noProof="0" dirty="0">
+                <a:ln>
+                  <a:noFill/>
+                </a:ln>
+                <a:solidFill>
+                  <a:srgbClr val="2C2A28"/>
+                </a:solidFill>
+                <a:effectLst/>
+                <a:uLnTx/>
+                <a:uFillTx/>
+                <a:latin typeface="CIBFont Sans Light" panose="020B0603020202020104" pitchFamily="34" charset="0"/>
+                <a:ea typeface="+mn-ea"/>
+                <a:cs typeface="+mn-cs"/>
+              </a:rPr>
+              <a:t>Selección </a:t>
+            </a:r>
+          </a:p>
+          <a:p>
+            <a:pPr marL="0" marR="0" lvl="0" indent="0" algn="ctr" defTabSz="914400" rtl="0" eaLnBrk="1" fontAlgn="auto" latinLnBrk="0" hangingPunct="1">
+              <a:lnSpc>
+                <a:spcPct val="100000"/>
+              </a:lnSpc>
+              <a:spcBef>
+                <a:spcPts val="0"/>
+              </a:spcBef>
+              <a:spcAft>
+                <a:spcPts val="0"/>
+              </a:spcAft>
+              <a:buClrTx/>
+              <a:buSzTx/>
+              <a:buFontTx/>
+              <a:buNone/>
+              <a:tabLst/>
+              <a:defRPr/>
+            </a:pPr>
+            <a:r>
+              <a:rPr kumimoji="0" lang="es-CO" sz="1100" b="1" i="0" u="none" strike="noStrike" kern="1200" cap="none" spc="0" normalizeH="0" baseline="0" noProof="0" dirty="0">
+                <a:ln>
+                  <a:noFill/>
+                </a:ln>
+                <a:solidFill>
+                  <a:srgbClr val="2C2A28"/>
+                </a:solidFill>
+                <a:effectLst/>
+                <a:uLnTx/>
+                <a:uFillTx/>
+                <a:latin typeface="CIBFont Sans Light" panose="020B0603020202020104" pitchFamily="34" charset="0"/>
+                <a:ea typeface="+mn-ea"/>
+                <a:cs typeface="+mn-cs"/>
+              </a:rPr>
+              <a:t>agente</a:t>
+            </a:r>
+          </a:p>
+        </p:txBody>
+      </p:sp>
+      <p:cxnSp>
+        <p:nvCxnSpPr>
+          <p:cNvPr id="144" name="Conector recto de flecha 143">
+            <a:extLst>
+              <a:ext uri="{FF2B5EF4-FFF2-40B4-BE49-F238E27FC236}">
+                <a16:creationId xmlns:a16="http://schemas.microsoft.com/office/drawing/2014/main" id="{AC42D29E-F144-37BD-F54C-9315A419D477}"/>
+              </a:ext>
+            </a:extLst>
+          </p:cNvPr>
+          <p:cNvCxnSpPr>
+            <a:cxnSpLocks/>
+            <a:stCxn id="129" idx="3"/>
+            <a:endCxn id="127" idx="1"/>
+          </p:cNvCxnSpPr>
+          <p:nvPr/>
+        </p:nvCxnSpPr>
+        <p:spPr>
+          <a:xfrm flipV="1">
+            <a:off x="9495153" y="2841938"/>
+            <a:ext cx="587579" cy="1000"/>
+          </a:xfrm>
+          <a:prstGeom prst="straightConnector1">
+            <a:avLst/>
+          </a:prstGeom>
+          <a:ln>
+            <a:tailEnd type="triangle"/>
+          </a:ln>
+        </p:spPr>
+        <p:style>
+          <a:lnRef idx="2">
+            <a:schemeClr val="dk1"/>
+          </a:lnRef>
+          <a:fillRef idx="0">
+            <a:schemeClr val="dk1"/>
+          </a:fillRef>
+          <a:effectRef idx="1">
+            <a:schemeClr val="dk1"/>
+          </a:effectRef>
+          <a:fontRef idx="minor">
+            <a:schemeClr val="tx1"/>
+          </a:fontRef>
+        </p:style>
+      </p:cxnSp>
+      <p:sp>
+        <p:nvSpPr>
+          <p:cNvPr id="155" name="CuadroTexto 154">
+            <a:extLst>
+              <a:ext uri="{FF2B5EF4-FFF2-40B4-BE49-F238E27FC236}">
+                <a16:creationId xmlns:a16="http://schemas.microsoft.com/office/drawing/2014/main" id="{7B5BE8CC-5358-7DB7-E145-3D9DBBFFCCE4}"/>
+              </a:ext>
+            </a:extLst>
+          </p:cNvPr>
+          <p:cNvSpPr txBox="1"/>
+          <p:nvPr/>
+        </p:nvSpPr>
+        <p:spPr>
+          <a:xfrm>
+            <a:off x="9873413" y="3206724"/>
+            <a:ext cx="1192277" cy="261610"/>
+          </a:xfrm>
+          <a:prstGeom prst="rect">
+            <a:avLst/>
+          </a:prstGeom>
+          <a:noFill/>
+        </p:spPr>
+        <p:txBody>
+          <a:bodyPr wrap="square">
+            <a:spAutoFit/>
+          </a:bodyPr>
+          <a:lstStyle/>
+          <a:p>
+            <a:pPr marL="0" marR="0" lvl="0" indent="0" algn="ctr" defTabSz="914400" rtl="0" eaLnBrk="1" fontAlgn="auto" latinLnBrk="0" hangingPunct="1">
+              <a:lnSpc>
+                <a:spcPct val="100000"/>
+              </a:lnSpc>
+              <a:spcBef>
+                <a:spcPts val="0"/>
+              </a:spcBef>
+              <a:spcAft>
+                <a:spcPts val="0"/>
+              </a:spcAft>
+              <a:buClrTx/>
+              <a:buSzTx/>
+              <a:buFontTx/>
+              <a:buNone/>
+              <a:tabLst/>
+              <a:defRPr/>
+            </a:pPr>
+            <a:r>
+              <a:rPr kumimoji="0" lang="es-CO" sz="1100" b="1" i="0" u="none" strike="noStrike" kern="1200" cap="none" spc="0" normalizeH="0" baseline="0" noProof="0" dirty="0">
+                <a:ln>
+                  <a:noFill/>
+                </a:ln>
+                <a:solidFill>
+                  <a:srgbClr val="2C2A28"/>
+                </a:solidFill>
+                <a:effectLst/>
+                <a:uLnTx/>
+                <a:uFillTx/>
+                <a:latin typeface="CIBFont Sans Light" panose="020B0603020202020104" pitchFamily="34" charset="0"/>
+                <a:ea typeface="+mn-ea"/>
+                <a:cs typeface="+mn-cs"/>
+              </a:rPr>
+              <a:t>Ejecución acción</a:t>
+            </a:r>
+          </a:p>
+        </p:txBody>
+      </p:sp>
+      <p:pic>
+        <p:nvPicPr>
+          <p:cNvPr id="161" name="Imagen 160">
+            <a:extLst>
+              <a:ext uri="{FF2B5EF4-FFF2-40B4-BE49-F238E27FC236}">
+                <a16:creationId xmlns:a16="http://schemas.microsoft.com/office/drawing/2014/main" id="{0F913098-FEEA-AB5C-F7D6-AE7BC073262F}"/>
+              </a:ext>
+            </a:extLst>
+          </p:cNvPr>
+          <p:cNvPicPr>
+            <a:picLocks noChangeAspect="1"/>
+          </p:cNvPicPr>
+          <p:nvPr/>
+        </p:nvPicPr>
+        <p:blipFill>
+          <a:blip r:embed="rId4"/>
+          <a:stretch>
+            <a:fillRect/>
+          </a:stretch>
+        </p:blipFill>
+        <p:spPr>
+          <a:xfrm>
+            <a:off x="8258066" y="5743964"/>
+            <a:ext cx="801697" cy="801697"/>
+          </a:xfrm>
+          <a:prstGeom prst="rect">
+            <a:avLst/>
+          </a:prstGeom>
+        </p:spPr>
+      </p:pic>
+      <p:sp>
+        <p:nvSpPr>
+          <p:cNvPr id="164" name="CuadroTexto 163">
+            <a:extLst>
+              <a:ext uri="{FF2B5EF4-FFF2-40B4-BE49-F238E27FC236}">
+                <a16:creationId xmlns:a16="http://schemas.microsoft.com/office/drawing/2014/main" id="{5E5FA6F5-0DF9-61EB-5385-DE7922A63A93}"/>
+              </a:ext>
+            </a:extLst>
+          </p:cNvPr>
+          <p:cNvSpPr txBox="1"/>
+          <p:nvPr/>
+        </p:nvSpPr>
+        <p:spPr>
+          <a:xfrm>
+            <a:off x="7978498" y="6596390"/>
+            <a:ext cx="1192277" cy="261610"/>
+          </a:xfrm>
+          <a:prstGeom prst="rect">
+            <a:avLst/>
+          </a:prstGeom>
+          <a:noFill/>
+        </p:spPr>
+        <p:txBody>
+          <a:bodyPr wrap="square">
+            <a:spAutoFit/>
+          </a:bodyPr>
+          <a:lstStyle/>
+          <a:p>
+            <a:pPr marL="0" marR="0" lvl="0" indent="0" algn="ctr" defTabSz="914400" rtl="0" eaLnBrk="1" fontAlgn="auto" latinLnBrk="0" hangingPunct="1">
+              <a:lnSpc>
+                <a:spcPct val="100000"/>
+              </a:lnSpc>
+              <a:spcBef>
+                <a:spcPts val="0"/>
+              </a:spcBef>
+              <a:spcAft>
+                <a:spcPts val="0"/>
+              </a:spcAft>
+              <a:buClrTx/>
+              <a:buSzTx/>
+              <a:buFontTx/>
+              <a:buNone/>
+              <a:tabLst/>
+              <a:defRPr/>
+            </a:pPr>
+            <a:r>
+              <a:rPr kumimoji="0" lang="es-CO" sz="1100" b="1" i="0" u="none" strike="noStrike" kern="1200" cap="none" spc="0" normalizeH="0" baseline="0" noProof="0" dirty="0">
+                <a:ln>
+                  <a:noFill/>
+                </a:ln>
+                <a:solidFill>
+                  <a:srgbClr val="2C2A28"/>
+                </a:solidFill>
+                <a:effectLst/>
+                <a:uLnTx/>
+                <a:uFillTx/>
+                <a:latin typeface="CIBFont Sans Light" panose="020B0603020202020104" pitchFamily="34" charset="0"/>
+                <a:ea typeface="+mn-ea"/>
+                <a:cs typeface="+mn-cs"/>
+              </a:rPr>
+              <a:t>Cliente</a:t>
+            </a:r>
+          </a:p>
+        </p:txBody>
+      </p:sp>
+      <p:cxnSp>
+        <p:nvCxnSpPr>
+          <p:cNvPr id="165" name="Conector recto de flecha 164">
+            <a:extLst>
+              <a:ext uri="{FF2B5EF4-FFF2-40B4-BE49-F238E27FC236}">
+                <a16:creationId xmlns:a16="http://schemas.microsoft.com/office/drawing/2014/main" id="{7B99EB95-F378-9752-56FE-9834A8E1F897}"/>
+              </a:ext>
+            </a:extLst>
+          </p:cNvPr>
+          <p:cNvCxnSpPr>
+            <a:cxnSpLocks/>
+          </p:cNvCxnSpPr>
+          <p:nvPr/>
+        </p:nvCxnSpPr>
+        <p:spPr>
+          <a:xfrm>
+            <a:off x="8443828" y="5153490"/>
+            <a:ext cx="0" cy="567192"/>
+          </a:xfrm>
+          <a:prstGeom prst="straightConnector1">
+            <a:avLst/>
+          </a:prstGeom>
+          <a:ln w="57150">
+            <a:tailEnd type="triangle"/>
+          </a:ln>
+        </p:spPr>
+        <p:style>
+          <a:lnRef idx="2">
+            <a:schemeClr val="dk1"/>
+          </a:lnRef>
+          <a:fillRef idx="0">
+            <a:schemeClr val="dk1"/>
+          </a:fillRef>
+          <a:effectRef idx="1">
+            <a:schemeClr val="dk1"/>
+          </a:effectRef>
+          <a:fontRef idx="minor">
+            <a:schemeClr val="tx1"/>
+          </a:fontRef>
+        </p:style>
+      </p:cxnSp>
+      <p:cxnSp>
+        <p:nvCxnSpPr>
+          <p:cNvPr id="167" name="Conector recto de flecha 166">
+            <a:extLst>
+              <a:ext uri="{FF2B5EF4-FFF2-40B4-BE49-F238E27FC236}">
+                <a16:creationId xmlns:a16="http://schemas.microsoft.com/office/drawing/2014/main" id="{9256A8EC-5C6C-86C5-0A3B-D80D1331A22D}"/>
+              </a:ext>
+            </a:extLst>
+          </p:cNvPr>
+          <p:cNvCxnSpPr>
+            <a:cxnSpLocks/>
+          </p:cNvCxnSpPr>
+          <p:nvPr/>
+        </p:nvCxnSpPr>
+        <p:spPr>
+          <a:xfrm flipV="1">
+            <a:off x="8658915" y="5126079"/>
+            <a:ext cx="0" cy="543516"/>
+          </a:xfrm>
+          <a:prstGeom prst="straightConnector1">
+            <a:avLst/>
+          </a:prstGeom>
+          <a:ln w="57150">
+            <a:tailEnd type="triangle"/>
+          </a:ln>
+        </p:spPr>
+        <p:style>
+          <a:lnRef idx="2">
+            <a:schemeClr val="dk1"/>
+          </a:lnRef>
+          <a:fillRef idx="0">
+            <a:schemeClr val="dk1"/>
+          </a:fillRef>
+          <a:effectRef idx="1">
+            <a:schemeClr val="dk1"/>
+          </a:effectRef>
+          <a:fontRef idx="minor">
+            <a:schemeClr val="tx1"/>
+          </a:fontRef>
+        </p:style>
+      </p:cxnSp>
+      <p:sp>
+        <p:nvSpPr>
+          <p:cNvPr id="174" name="CuadroTexto 173">
+            <a:extLst>
+              <a:ext uri="{FF2B5EF4-FFF2-40B4-BE49-F238E27FC236}">
+                <a16:creationId xmlns:a16="http://schemas.microsoft.com/office/drawing/2014/main" id="{6711966F-231F-7EDC-4BE5-A6786EBA454B}"/>
+              </a:ext>
+            </a:extLst>
+          </p:cNvPr>
+          <p:cNvSpPr txBox="1"/>
+          <p:nvPr/>
+        </p:nvSpPr>
+        <p:spPr>
+          <a:xfrm>
+            <a:off x="8708515" y="5314838"/>
+            <a:ext cx="838990" cy="261610"/>
+          </a:xfrm>
+          <a:prstGeom prst="rect">
+            <a:avLst/>
+          </a:prstGeom>
+          <a:noFill/>
+        </p:spPr>
+        <p:txBody>
+          <a:bodyPr wrap="square">
+            <a:spAutoFit/>
+          </a:bodyPr>
+          <a:lstStyle/>
+          <a:p>
+            <a:pPr marL="0" marR="0" lvl="0" indent="0" algn="ctr" defTabSz="914400" rtl="0" eaLnBrk="1" fontAlgn="auto" latinLnBrk="0" hangingPunct="1">
+              <a:lnSpc>
+                <a:spcPct val="100000"/>
+              </a:lnSpc>
+              <a:spcBef>
+                <a:spcPts val="0"/>
+              </a:spcBef>
+              <a:spcAft>
+                <a:spcPts val="0"/>
+              </a:spcAft>
+              <a:buClrTx/>
+              <a:buSzTx/>
+              <a:buFontTx/>
+              <a:buNone/>
+              <a:tabLst/>
+              <a:defRPr/>
+            </a:pPr>
+            <a:r>
+              <a:rPr kumimoji="0" lang="es-CO" sz="1100" b="1" i="0" u="none" strike="noStrike" kern="1200" cap="none" spc="0" normalizeH="0" baseline="0" noProof="0" dirty="0">
+                <a:ln>
+                  <a:noFill/>
+                </a:ln>
+                <a:solidFill>
+                  <a:srgbClr val="2C2A28"/>
+                </a:solidFill>
+                <a:effectLst/>
+                <a:uLnTx/>
+                <a:uFillTx/>
+                <a:latin typeface="CIBFont Sans Light" panose="020B0603020202020104" pitchFamily="34" charset="0"/>
+                <a:ea typeface="+mn-ea"/>
+                <a:cs typeface="+mn-cs"/>
+              </a:rPr>
+              <a:t>Interacción</a:t>
+            </a:r>
+          </a:p>
+        </p:txBody>
+      </p:sp>
+    </p:spTree>
+    <p:extLst>
+      <p:ext uri="{BB962C8B-B14F-4D97-AF65-F5344CB8AC3E}">
+        <p14:creationId xmlns:p14="http://schemas.microsoft.com/office/powerpoint/2010/main" val="2738795699"/>
       </p:ext>
     </p:extLst>
   </p:cSld>

</xml_diff>